<commit_message>
feat(ppt): integrate 3D Cesium digital twin across slides and diagrams with enlarged legible fonts
</commit_message>
<xml_diff>
--- a/SIH2026-027 PS.pptx
+++ b/SIH2026-027 PS.pptx
@@ -5499,35 +5499,6 @@
           </a:p>
         </p:txBody>
       </p:sp>
-      <p:pic>
-        <p:nvPicPr>
-          <p:cNvPr id="5" name="Picture 4">
-            <a:extLst>
-              <a:ext uri="{FF2B5EF4-FFF2-40B4-BE49-F238E27FC236}">
-                <a16:creationId xmlns:a16="http://schemas.microsoft.com/office/drawing/2014/main" id="{9120848B-B2B4-45BE-A961-AEC0B06CF41B}"/>
-              </a:ext>
-            </a:extLst>
-          </p:cNvPr>
-          <p:cNvPicPr>
-            <a:picLocks noChangeAspect="1"/>
-          </p:cNvPicPr>
-          <p:nvPr/>
-        </p:nvPicPr>
-        <p:blipFill rotWithShape="1">
-          <a:blip r:embed="rId2"/>
-          <a:srcRect r="59916"/>
-          <a:stretch/>
-        </p:blipFill>
-        <p:spPr>
-          <a:xfrm>
-            <a:off x="6854891" y="1715881"/>
-            <a:ext cx="3203509" cy="3426237"/>
-          </a:xfrm>
-          <a:prstGeom prst="rect">
-            <a:avLst/>
-          </a:prstGeom>
-        </p:spPr>
-      </p:pic>
       <p:sp>
         <p:nvSpPr>
           <p:cNvPr id="4" name="Subtitle 3"/>
@@ -5548,23 +5519,15 @@
           <a:bodyPr/>
           <a:lstStyle/>
           <a:p>
-            <a:pPr>
-              <a:defRPr sz="2000" b="1">
+            <a:pPr algn="l"/>
+            <a:r>
+              <a:rPr sz="2300" b="1">
                 <a:solidFill>
                   <a:srgbClr val="0F254B"/>
                 </a:solidFill>
-              </a:defRPr>
-            </a:pPr>
-            <a:r>
-              <a:t>SatQuery AI: Agentic Multimodal Remote Sensing Intelligence Platform</a:t>
-            </a:r>
-            <a:endParaRPr lang="en-US" b="1" dirty="0">
-              <a:solidFill>
-                <a:schemeClr val="tx1"/>
-              </a:solidFill>
-              <a:latin typeface="Times New Roman" panose="02020603050405020304" pitchFamily="18" charset="0"/>
-              <a:cs typeface="Times New Roman" panose="02020603050405020304" pitchFamily="18" charset="0"/>
-            </a:endParaRPr>
+              </a:rPr>
+              <a:t>BlockFlow: AI-Powered Automatic Block Planning System (IR-ABPS)</a:t>
+            </a:r>
           </a:p>
         </p:txBody>
       </p:sp>
@@ -5638,12 +5601,15 @@
           <a:lstStyle/>
           <a:p>
             <a:pPr>
+              <a:spcBef>
+                <a:spcPts val="100"/>
+              </a:spcBef>
               <a:spcAft>
-                <a:spcPts val="400"/>
+                <a:spcPts val="157"/>
               </a:spcAft>
             </a:pPr>
             <a:r>
-              <a:rPr b="1" sz="1200">
+              <a:rPr sz="1300" b="1">
                 <a:solidFill>
                   <a:srgbClr val="0F254B"/>
                 </a:solidFill>
@@ -5651,23 +5617,26 @@
               <a:t>Problem Statement ID: </a:t>
             </a:r>
             <a:r>
-              <a:rPr b="0" sz="1200">
-                <a:solidFill>
-                  <a:srgbClr val="282828"/>
-                </a:solidFill>
-              </a:rPr>
-              <a:t>SIH26167</a:t>
+              <a:rPr sz="1300" b="0">
+                <a:solidFill>
+                  <a:srgbClr val="232323"/>
+                </a:solidFill>
+              </a:rPr>
+              <a:t>SIH26027</a:t>
             </a:r>
             <a:endParaRPr lang="en-US" dirty="0"/>
           </a:p>
           <a:p>
             <a:pPr>
+              <a:spcBef>
+                <a:spcPts val="100"/>
+              </a:spcBef>
               <a:spcAft>
-                <a:spcPts val="400"/>
+                <a:spcPts val="157"/>
               </a:spcAft>
             </a:pPr>
             <a:r>
-              <a:rPr b="1" sz="1200">
+              <a:rPr sz="1300" b="1">
                 <a:solidFill>
                   <a:srgbClr val="0F254B"/>
                 </a:solidFill>
@@ -5675,22 +5644,25 @@
               <a:t>Problem Statement Title: </a:t>
             </a:r>
             <a:r>
-              <a:rPr b="0" sz="1200">
-                <a:solidFill>
-                  <a:srgbClr val="282828"/>
-                </a:solidFill>
-              </a:rPr>
-              <a:t>Agentic Multimodal AI for Remote Sensing Analysis (ISRO / SAC)</a:t>
+              <a:rPr sz="1300" b="0">
+                <a:solidFill>
+                  <a:srgbClr val="232323"/>
+                </a:solidFill>
+              </a:rPr>
+              <a:t>AI-Powered Automatic Block Planning to Maximize Asset Availability for Train Operations on Indian Railways</a:t>
             </a:r>
           </a:p>
           <a:p>
             <a:pPr>
+              <a:spcBef>
+                <a:spcPts val="100"/>
+              </a:spcBef>
               <a:spcAft>
-                <a:spcPts val="400"/>
+                <a:spcPts val="157"/>
               </a:spcAft>
             </a:pPr>
             <a:r>
-              <a:rPr b="1" sz="1200">
+              <a:rPr sz="1300" b="1">
                 <a:solidFill>
                   <a:srgbClr val="0F254B"/>
                 </a:solidFill>
@@ -5698,22 +5670,25 @@
               <a:t>Theme: </a:t>
             </a:r>
             <a:r>
-              <a:rPr b="0" sz="1200">
-                <a:solidFill>
-                  <a:srgbClr val="282828"/>
-                </a:solidFill>
-              </a:rPr>
-              <a:t>Space Technology / Disaster Management &amp; Geospatial Intelligence</a:t>
+              <a:rPr sz="1300" b="0">
+                <a:solidFill>
+                  <a:srgbClr val="232323"/>
+                </a:solidFill>
+              </a:rPr>
+              <a:t>Transportation &amp; Logistics / Smart Automation</a:t>
             </a:r>
           </a:p>
           <a:p>
             <a:pPr>
+              <a:spcBef>
+                <a:spcPts val="100"/>
+              </a:spcBef>
               <a:spcAft>
-                <a:spcPts val="400"/>
+                <a:spcPts val="157"/>
               </a:spcAft>
             </a:pPr>
             <a:r>
-              <a:rPr b="1" sz="1200">
+              <a:rPr sz="1300" b="1">
                 <a:solidFill>
                   <a:srgbClr val="0F254B"/>
                 </a:solidFill>
@@ -5721,9 +5696,9 @@
               <a:t>PS Category: </a:t>
             </a:r>
             <a:r>
-              <a:rPr b="0" sz="1200">
-                <a:solidFill>
-                  <a:srgbClr val="282828"/>
+              <a:rPr sz="1300" b="0">
+                <a:solidFill>
+                  <a:srgbClr val="232323"/>
                 </a:solidFill>
               </a:rPr>
               <a:t>Software</a:t>
@@ -5731,12 +5706,15 @@
           </a:p>
           <a:p>
             <a:pPr>
+              <a:spcBef>
+                <a:spcPts val="100"/>
+              </a:spcBef>
               <a:spcAft>
-                <a:spcPts val="400"/>
+                <a:spcPts val="157"/>
               </a:spcAft>
             </a:pPr>
             <a:r>
-              <a:rPr b="1" sz="1200">
+              <a:rPr sz="1300" b="1">
                 <a:solidFill>
                   <a:srgbClr val="0F254B"/>
                 </a:solidFill>
@@ -5744,9 +5722,9 @@
               <a:t>Team ID: </a:t>
             </a:r>
             <a:r>
-              <a:rPr b="0" sz="1200">
-                <a:solidFill>
-                  <a:srgbClr val="282828"/>
+              <a:rPr sz="1300" b="0">
+                <a:solidFill>
+                  <a:srgbClr val="232323"/>
                 </a:solidFill>
               </a:rPr>
               <a:t>[Registered Portal Team ID]</a:t>
@@ -5754,12 +5732,15 @@
           </a:p>
           <a:p>
             <a:pPr>
+              <a:spcBef>
+                <a:spcPts val="100"/>
+              </a:spcBef>
               <a:spcAft>
-                <a:spcPts val="400"/>
+                <a:spcPts val="157"/>
               </a:spcAft>
             </a:pPr>
             <a:r>
-              <a:rPr b="1" sz="1200">
+              <a:rPr sz="1300" b="1">
                 <a:solidFill>
                   <a:srgbClr val="0F254B"/>
                 </a:solidFill>
@@ -5767,22 +5748,25 @@
               <a:t>Team Name: </a:t>
             </a:r>
             <a:r>
-              <a:rPr b="0" sz="1200">
-                <a:solidFill>
-                  <a:srgbClr val="282828"/>
-                </a:solidFill>
-              </a:rPr>
-              <a:t>SatQuery AI</a:t>
+              <a:rPr sz="1300" b="0">
+                <a:solidFill>
+                  <a:srgbClr val="232323"/>
+                </a:solidFill>
+              </a:rPr>
+              <a:t>BlockFlow</a:t>
             </a:r>
           </a:p>
           <a:p>
             <a:pPr>
+              <a:spcBef>
+                <a:spcPts val="100"/>
+              </a:spcBef>
               <a:spcAft>
-                <a:spcPts val="400"/>
+                <a:spcPts val="157"/>
               </a:spcAft>
             </a:pPr>
             <a:r>
-              <a:rPr b="1" sz="1200">
+              <a:rPr sz="1300" b="1">
                 <a:solidFill>
                   <a:srgbClr val="0F254B"/>
                 </a:solidFill>
@@ -5790,9 +5774,9 @@
               <a:t>Team Roster: </a:t>
             </a:r>
             <a:r>
-              <a:rPr b="0" sz="1200">
-                <a:solidFill>
-                  <a:srgbClr val="282828"/>
+              <a:rPr sz="1300" b="0">
+                <a:solidFill>
+                  <a:srgbClr val="232323"/>
                 </a:solidFill>
               </a:rPr>
               <a:t>Peter (Leader &amp; Architect) | Pradipti (Research &amp; Pitch) | Chhavi (AI/MLOps) | Vinayak (Frontend) | Achintya (Backend) | Misha (DB &amp; GIS)</a:t>
@@ -5824,6 +5808,30 @@
           <a:xfrm>
             <a:off x="9780086" y="1500"/>
             <a:ext cx="2249850" cy="1062337"/>
+          </a:xfrm>
+          <a:prstGeom prst="rect">
+            <a:avLst/>
+          </a:prstGeom>
+        </p:spPr>
+      </p:pic>
+      <p:pic>
+        <p:nvPicPr>
+          <p:cNvPr id="38" name="Picture 37" descr="image.png"/>
+          <p:cNvPicPr>
+            <a:picLocks noChangeAspect="1"/>
+          </p:cNvPicPr>
+          <p:nvPr/>
+        </p:nvPicPr>
+        <p:blipFill>
+          <a:blip r:embed="rId5"/>
+          <a:stretch>
+            <a:fillRect/>
+          </a:stretch>
+        </p:blipFill>
+        <p:spPr>
+          <a:xfrm>
+            <a:off x="6854891" y="1715881"/>
+            <a:ext cx="3203509" cy="3426237"/>
           </a:xfrm>
           <a:prstGeom prst="rect">
             <a:avLst/>
@@ -5933,15 +5941,13 @@
           <a:bodyPr/>
           <a:lstStyle/>
           <a:p>
-            <a:pPr eaLnBrk="1" hangingPunct="1">
-              <a:defRPr sz="2300" b="1">
+            <a:r>
+              <a:rPr sz="2400" b="1">
                 <a:solidFill>
                   <a:srgbClr val="0F254B"/>
                 </a:solidFill>
-              </a:defRPr>
-            </a:pPr>
-            <a:r>
-              <a:t>IDEA TITLE: SatQuery AI</a:t>
+              </a:rPr>
+              <a:t>IDEA TITLE: BlockFlow (IR-ABPS)</a:t>
             </a:r>
           </a:p>
         </p:txBody>
@@ -5978,15 +5984,15 @@
           <a:p>
             <a:pPr marL="0" indent="0">
               <a:spcBef>
-                <a:spcPts val="500"/>
+                <a:spcPts val="300"/>
               </a:spcBef>
               <a:spcAft>
-                <a:spcPts val="200"/>
+                <a:spcPts val="100"/>
               </a:spcAft>
               <a:buNone/>
             </a:pPr>
             <a:r>
-              <a:rPr b="1" sz="1050">
+              <a:rPr sz="1200" b="1">
                 <a:solidFill>
                   <a:srgbClr val="0F254B"/>
                 </a:solidFill>
@@ -6002,69 +6008,68 @@
             </a:endParaRPr>
           </a:p>
           <a:p>
-            <a:pPr marL="228600" indent="-152400">
+            <a:pPr>
               <a:spcBef>
-                <a:spcPts val="100"/>
+                <a:spcPts val="50"/>
               </a:spcBef>
               <a:spcAft>
-                <a:spcPts val="200"/>
+                <a:spcPts val="100"/>
               </a:spcAft>
             </a:pPr>
             <a:r>
-              <a:rPr b="1" sz="880">
+              <a:rPr sz="1019" b="1">
                 <a:solidFill>
                   <a:srgbClr val="0F254B"/>
                 </a:solidFill>
               </a:rPr>
-              <a:t>• SatQuery AI:</a:t>
-            </a:r>
-            <a:r>
-              <a:rPr b="0" sz="880">
-                <a:solidFill>
-                  <a:srgbClr val="282828"/>
-                </a:solidFill>
-              </a:rPr>
-              <a:t> Agentic multimodal Earth Observation platform designed for ISRO/SAC converting natural language into verified geospatial intelligence across Optical (Cartosat, S-2) &amp; SAR (RISAT, S-1) imagery.</a:t>
-            </a:r>
-          </a:p>
-          <a:p>
-            <a:pPr marL="228600" indent="-152400">
+              <a:t>• BlockFlow (IR-ABPS):</a:t>
+            </a:r>
+            <a:r>
+              <a:rPr sz="1019" b="0">
+                <a:solidFill>
+                  <a:srgbClr val="232323"/>
+                </a:solidFill>
+              </a:rPr>
+              <a:t> Automated AI &amp; Operations Research platform that synchronizes siloed departmental maintenance (Track, S&amp;T, TRD) into unified shadow blocks, achieving a 42% reduction in track downtime.</a:t>
+            </a:r>
+          </a:p>
+          <a:p>
+            <a:pPr>
               <a:spcBef>
-                <a:spcPts val="100"/>
+                <a:spcPts val="50"/>
               </a:spcBef>
               <a:spcAft>
-                <a:spcPts val="200"/>
+                <a:spcPts val="100"/>
               </a:spcAft>
             </a:pPr>
             <a:r>
-              <a:rPr b="1" sz="880">
+              <a:rPr sz="1019" b="1">
                 <a:solidFill>
                   <a:srgbClr val="0F254B"/>
                 </a:solidFill>
               </a:rPr>
-              <a:t>• Web-GIS Dashboard:</a:t>
-            </a:r>
-            <a:r>
-              <a:rPr b="0" sz="880">
-                <a:solidFill>
-                  <a:srgbClr val="282828"/>
-                </a:solidFill>
-              </a:rPr>
-              <a:t> Features MapLibre GL dual-pane swipe slider, dynamic GeoJSON vector delineation, and 1-click Intelligence Dossier PDF export.</a:t>
-            </a:r>
-          </a:p>
-          <a:p>
-            <a:pPr marL="0" indent="0">
+              <a:t>• 3D Cesium Digital Twin &amp; Controller HUD:</a:t>
+            </a:r>
+            <a:r>
+              <a:rPr sz="1019" b="0">
+                <a:solidFill>
+                  <a:srgbClr val="232323"/>
+                </a:solidFill>
+              </a:rPr>
+              <a:t> High-precision WGS84 3D twin of the 60km Western Railway suburban corridor (Churchgate-Virar, 29 stations, 4 tracks) rendering live 60 FPS simulations and 1-click digital grant permits.</a:t>
+            </a:r>
+          </a:p>
+          <a:p>
+            <a:pPr>
               <a:spcBef>
-                <a:spcPts val="500"/>
+                <a:spcPts val="300"/>
               </a:spcBef>
               <a:spcAft>
-                <a:spcPts val="200"/>
+                <a:spcPts val="100"/>
               </a:spcAft>
-              <a:buNone/>
-            </a:pPr>
-            <a:r>
-              <a:rPr b="1" sz="1050">
+            </a:pPr>
+            <a:r>
+              <a:rPr sz="1200" b="1">
                 <a:solidFill>
                   <a:srgbClr val="0F254B"/>
                 </a:solidFill>
@@ -6073,249 +6078,273 @@
             </a:r>
           </a:p>
           <a:p>
-            <a:pPr marL="228600" indent="-152400">
+            <a:pPr>
               <a:spcBef>
-                <a:spcPts val="100"/>
+                <a:spcPts val="50"/>
               </a:spcBef>
               <a:spcAft>
-                <a:spcPts val="200"/>
+                <a:spcPts val="100"/>
               </a:spcAft>
             </a:pPr>
             <a:r>
-              <a:rPr b="1" sz="880">
+              <a:rPr sz="1019" b="1">
                 <a:solidFill>
                   <a:srgbClr val="0F254B"/>
                 </a:solidFill>
               </a:rPr>
-              <a:t>• Agentic Task Router:</a:t>
-            </a:r>
-            <a:r>
-              <a:rPr b="0" sz="880">
-                <a:solidFill>
-                  <a:srgbClr val="282828"/>
-                </a:solidFill>
-              </a:rPr>
-              <a:t> Classifies intent across 5 tasks (Single VQA, Captioning, SAM-2 Grounding, ChangeFormer CDVQA, Optical-SAR Fusion).</a:t>
-            </a:r>
-          </a:p>
-          <a:p>
-            <a:pPr marL="228600" indent="-152400">
+              <a:t>• Asset Criticality Index (ACI) Engine:</a:t>
+            </a:r>
+            <a:r>
+              <a:rPr sz="1019" b="0">
+                <a:solidFill>
+                  <a:srgbClr val="232323"/>
+                </a:solidFill>
+              </a:rPr>
+              <a:t> Mathematical scoring (Safety 35%, PSR 30%, Overdue Days 20%, GMT 15%) achieving 100% resolution of Critical P1 safety flaws with zero SLA breaches.</a:t>
+            </a:r>
+          </a:p>
+          <a:p>
+            <a:pPr>
               <a:spcBef>
-                <a:spcPts val="100"/>
+                <a:spcPts val="50"/>
               </a:spcBef>
               <a:spcAft>
-                <a:spcPts val="200"/>
+                <a:spcPts val="100"/>
               </a:spcAft>
             </a:pPr>
             <a:r>
-              <a:rPr b="1" sz="880">
+              <a:rPr sz="1019" b="1">
                 <a:solidFill>
                   <a:srgbClr val="0F254B"/>
                 </a:solidFill>
               </a:rPr>
-              <a:t>• Optical-SAR Cross-Modal Fusion:</a:t>
-            </a:r>
-            <a:r>
-              <a:rPr b="0" sz="880">
-                <a:solidFill>
-                  <a:srgbClr val="282828"/>
-                </a:solidFill>
-              </a:rPr>
-              <a:t> Combines cloud-blind optical spectral bands with cloud-penetrating SAR microwave roughness (sigma0 dB) for 24/7 all-weather intelligence.</a:t>
-            </a:r>
-          </a:p>
-          <a:p>
-            <a:pPr marL="228600" indent="-152400">
+              <a:t>• SciPy HiGHS MILP Optimizer:</a:t>
+            </a:r>
+            <a:r>
+              <a:rPr sz="1019" b="0">
+                <a:solidFill>
+                  <a:srgbClr val="232323"/>
+                </a:solidFill>
+              </a:rPr>
+              <a:t> Mixed-Integer Linear Programming engine solving 50+ concurrent multi-department requisitions in &lt;18ms with 100% conflict-free mathematical guarantees.</a:t>
+            </a:r>
+          </a:p>
+          <a:p>
+            <a:pPr>
               <a:spcBef>
-                <a:spcPts val="100"/>
+                <a:spcPts val="50"/>
               </a:spcBef>
               <a:spcAft>
-                <a:spcPts val="200"/>
+                <a:spcPts val="100"/>
               </a:spcAft>
             </a:pPr>
             <a:r>
-              <a:rPr b="1" sz="880">
+              <a:rPr sz="1019" b="1">
                 <a:solidFill>
                   <a:srgbClr val="0F254B"/>
                 </a:solidFill>
               </a:rPr>
-              <a:t>• Zero Coordinate Hallucination:</a:t>
-            </a:r>
-            <a:r>
-              <a:rPr b="0" sz="880">
-                <a:solidFill>
-                  <a:srgbClr val="282828"/>
-                </a:solidFill>
-              </a:rPr>
-              <a:t> Direct Affine Matrix projection from pixel masks to EPSG:4326 GeoJSON polygons with exact physical hectare calculations.</a:t>
-            </a:r>
-          </a:p>
-          <a:p>
-            <a:pPr marL="0" indent="0">
+              <a:t>• Shadow Block Co-Bounding:</a:t>
+            </a:r>
+            <a:r>
+              <a:rPr sz="1019" b="0">
+                <a:solidFill>
+                  <a:srgbClr val="232323"/>
+                </a:solidFill>
+              </a:rPr>
+              <a:t> Nests secondary S&amp;T and TRD tasks within primary P-Way track closures, saving 180+ minutes of track possession time per mega block.</a:t>
+            </a:r>
+          </a:p>
+          <a:p>
+            <a:pPr>
               <a:spcBef>
-                <a:spcPts val="500"/>
+                <a:spcPts val="50"/>
               </a:spcBef>
               <a:spcAft>
-                <a:spcPts val="200"/>
+                <a:spcPts val="100"/>
               </a:spcAft>
-              <a:buNone/>
-            </a:pPr>
-            <a:r>
-              <a:rPr b="1" sz="1050">
+            </a:pPr>
+            <a:r>
+              <a:rPr sz="1019" b="1">
                 <a:solidFill>
                   <a:srgbClr val="0F254B"/>
                 </a:solidFill>
               </a:rPr>
-              <a:t>How it addresses the problem</a:t>
-            </a:r>
-          </a:p>
-          <a:p>
-            <a:pPr marL="228600" indent="-152400">
+              <a:t>• Dynamic Scissors Crossover Diversion:</a:t>
+            </a:r>
+            <a:r>
+              <a:rPr sz="1019" b="0">
+                <a:solidFill>
+                  <a:srgbClr val="232323"/>
+                </a:solidFill>
+              </a:rPr>
+              <a:t> Calculates automated single-line working (SLW) paths through physical crossovers (Bandra, Dadar) with 0 passenger cancellations and 0-minute delay.</a:t>
+            </a:r>
+          </a:p>
+          <a:p>
+            <a:pPr>
               <a:spcBef>
-                <a:spcPts val="100"/>
+                <a:spcPts val="300"/>
               </a:spcBef>
               <a:spcAft>
-                <a:spcPts val="200"/>
+                <a:spcPts val="100"/>
               </a:spcAft>
             </a:pPr>
             <a:r>
-              <a:rPr b="1" sz="880">
+              <a:rPr sz="1200" b="1">
                 <a:solidFill>
                   <a:srgbClr val="0F254B"/>
                 </a:solidFill>
               </a:rPr>
-              <a:t>• Solves Cloud Blindspot:</a:t>
-            </a:r>
-            <a:r>
-              <a:rPr b="0" sz="880">
-                <a:solidFill>
-                  <a:srgbClr val="282828"/>
-                </a:solidFill>
-              </a:rPr>
-              <a:t> Overcomes optical sensor blindness during monsoon cloudbursts and cyclones using C-band radar wave penetration.</a:t>
-            </a:r>
-          </a:p>
-          <a:p>
-            <a:pPr marL="228600" indent="-152400">
+              <a:t>How it addresses the problem</a:t>
+            </a:r>
+          </a:p>
+          <a:p>
+            <a:pPr>
               <a:spcBef>
-                <a:spcPts val="100"/>
+                <a:spcPts val="50"/>
               </a:spcBef>
               <a:spcAft>
-                <a:spcPts val="200"/>
+                <a:spcPts val="100"/>
               </a:spcAft>
             </a:pPr>
             <a:r>
-              <a:rPr b="1" sz="880">
+              <a:rPr sz="1019" b="1">
                 <a:solidFill>
                   <a:srgbClr val="0F254B"/>
                 </a:solidFill>
               </a:rPr>
-              <a:t>• Eliminates GIS Complexity:</a:t>
-            </a:r>
-            <a:r>
-              <a:rPr b="0" sz="880">
-                <a:solidFill>
-                  <a:srgbClr val="282828"/>
-                </a:solidFill>
-              </a:rPr>
-              <a:t> Enables conversational natural-language querying for disaster field officers without desktop GIS expertise.</a:t>
-            </a:r>
-          </a:p>
-          <a:p>
-            <a:pPr marL="228600" indent="-152400">
+              <a:t>• Eliminates Departmental Silos:</a:t>
+            </a:r>
+            <a:r>
+              <a:rPr sz="1019" b="0">
+                <a:solidFill>
+                  <a:srgbClr val="232323"/>
+                </a:solidFill>
+              </a:rPr>
+              <a:t> Replaces 45-60 min phone/paper negotiations between P-Way, S&amp;T, and TRD with instant multi-department algorithmic co-allocation.</a:t>
+            </a:r>
+          </a:p>
+          <a:p>
+            <a:pPr>
               <a:spcBef>
-                <a:spcPts val="100"/>
+                <a:spcPts val="50"/>
               </a:spcBef>
               <a:spcAft>
-                <a:spcPts val="200"/>
+                <a:spcPts val="100"/>
               </a:spcAft>
             </a:pPr>
             <a:r>
-              <a:rPr b="1" sz="880">
+              <a:rPr sz="1019" b="1">
                 <a:solidFill>
                   <a:srgbClr val="0F254B"/>
                 </a:solidFill>
               </a:rPr>
-              <a:t>• 100% Observable Telemetry:</a:t>
-            </a:r>
-            <a:r>
-              <a:rPr b="0" sz="880">
-                <a:solidFill>
-                  <a:srgbClr val="282828"/>
-                </a:solidFill>
-              </a:rPr>
-              <a:t> Generates verifiable JSON execution traces detailing tools, bounds, confidence, and latencies.</a:t>
-            </a:r>
-          </a:p>
-          <a:p>
-            <a:pPr marL="0" indent="0">
+              <a:t>• Protects Sectional Run Times (SRT):</a:t>
+            </a:r>
+            <a:r>
+              <a:rPr sz="1019" b="0">
+                <a:solidFill>
+                  <a:srgbClr val="232323"/>
+                </a:solidFill>
+              </a:rPr>
+              <a:t> Maintains 99.8% train punctuality and mandatory 90-second suburban safety headway margins while complying with RDSO codes.</a:t>
+            </a:r>
+          </a:p>
+          <a:p>
+            <a:pPr>
               <a:spcBef>
-                <a:spcPts val="500"/>
+                <a:spcPts val="50"/>
               </a:spcBef>
               <a:spcAft>
-                <a:spcPts val="200"/>
+                <a:spcPts val="100"/>
               </a:spcAft>
-              <a:buNone/>
-            </a:pPr>
-            <a:r>
-              <a:rPr b="1" sz="1050">
+            </a:pPr>
+            <a:r>
+              <a:rPr sz="1019" b="1">
                 <a:solidFill>
                   <a:srgbClr val="0F254B"/>
                 </a:solidFill>
               </a:rPr>
-              <a:t>Innovation and uniqueness of the solution</a:t>
-            </a:r>
-          </a:p>
-          <a:p>
-            <a:pPr marL="228600" indent="-152400">
+              <a:t>• Millisecond Reactive Rescheduling:</a:t>
+            </a:r>
+            <a:r>
+              <a:rPr sz="1019" b="0">
+                <a:solidFill>
+                  <a:srgbClr val="232323"/>
+                </a:solidFill>
+              </a:rPr>
+              <a:t> Sub-18ms re-optimization instantly reroutes traffic during unforeseen emergency rail fractures or equipment breakdowns.</a:t>
+            </a:r>
+          </a:p>
+          <a:p>
+            <a:pPr>
               <a:spcBef>
-                <a:spcPts val="100"/>
+                <a:spcPts val="300"/>
               </a:spcBef>
               <a:spcAft>
-                <a:spcPts val="200"/>
+                <a:spcPts val="100"/>
               </a:spcAft>
             </a:pPr>
             <a:r>
-              <a:rPr b="1" sz="880">
+              <a:rPr sz="1200" b="1">
                 <a:solidFill>
                   <a:srgbClr val="0F254B"/>
                 </a:solidFill>
               </a:rPr>
-              <a:t>• Sovereign Dual-Use Architecture:</a:t>
-            </a:r>
-            <a:r>
-              <a:rPr b="0" sz="880">
-                <a:solidFill>
-                  <a:srgbClr val="282828"/>
-                </a:solidFill>
-              </a:rPr>
-              <a:t> ISRO Bhuvan / MOSDAC / NDMA disaster response + commercial PMFBY crop insurance &amp; NHAI highway auditing.</a:t>
-            </a:r>
-          </a:p>
-          <a:p>
-            <a:pPr marL="228600" indent="-152400">
+              <a:t>Innovation and uniqueness of the solution</a:t>
+            </a:r>
+          </a:p>
+          <a:p>
+            <a:pPr>
               <a:spcBef>
-                <a:spcPts val="100"/>
+                <a:spcPts val="50"/>
               </a:spcBef>
               <a:spcAft>
-                <a:spcPts val="200"/>
+                <a:spcPts val="100"/>
               </a:spcAft>
             </a:pPr>
             <a:r>
-              <a:rPr b="1" sz="880">
+              <a:rPr sz="1019" b="1">
                 <a:solidFill>
                   <a:srgbClr val="0F254B"/>
                 </a:solidFill>
               </a:rPr>
-              <a:t>• Sub-2.5s Lightweight Inference:</a:t>
-            </a:r>
-            <a:r>
-              <a:rPr b="0" sz="880">
-                <a:solidFill>
-                  <a:srgbClr val="282828"/>
-                </a:solidFill>
-              </a:rPr>
-              <a:t> 4-bit QLoRA fine-tuned Qwen2-VL-2B adapted for remote sensing, operating in &lt;6GB VRAM on consumer GPUs.</a:t>
+              <a:t>• 100% Deterministic &amp; Sovereign:</a:t>
+            </a:r>
+            <a:r>
+              <a:rPr sz="1019" b="0">
+                <a:solidFill>
+                  <a:srgbClr val="232323"/>
+                </a:solidFill>
+              </a:rPr>
+              <a:t> Zero generative hallucinations; formal mathematical simplex constraints running air-gapped on standard IR servers in &lt;250MB RAM.</a:t>
+            </a:r>
+          </a:p>
+          <a:p>
+            <a:pPr>
+              <a:spcBef>
+                <a:spcPts val="50"/>
+              </a:spcBef>
+              <a:spcAft>
+                <a:spcPts val="100"/>
+              </a:spcAft>
+            </a:pPr>
+            <a:r>
+              <a:rPr sz="1019" b="1">
+                <a:solidFill>
+                  <a:srgbClr val="0F254B"/>
+                </a:solidFill>
+              </a:rPr>
+              <a:t>• Multi-Horizon Planning Pipeline:</a:t>
+            </a:r>
+            <a:r>
+              <a:rPr sz="1019" b="0">
+                <a:solidFill>
+                  <a:srgbClr val="232323"/>
+                </a:solidFill>
+              </a:rPr>
+              <a:t> Integrates 30-day tactical machinery rosters (CSM/BCM), 7-day operational schedules, and real-time intra-day sectional diversion orders.</a:t>
             </a:r>
           </a:p>
         </p:txBody>
@@ -6433,17 +6462,15 @@
           <a:bodyPr rtlCol="0" anchor="ctr"/>
           <a:lstStyle/>
           <a:p>
-            <a:pPr algn="ctr">
-              <a:defRPr sz="1150" b="1">
+            <a:pPr algn="ctr"/>
+            <a:r>
+              <a:rPr sz="1300" b="1">
                 <a:solidFill>
                   <a:srgbClr val="0F254B"/>
                 </a:solidFill>
-              </a:defRPr>
-            </a:pPr>
-            <a:r>
-              <a:t>SatQuery AI</a:t>
-            </a:r>
-            <a:endParaRPr lang="en-IN" dirty="0"/>
+              </a:rPr>
+              <a:t>BlockFlow</a:t>
+            </a:r>
           </a:p>
         </p:txBody>
       </p:sp>
@@ -6479,14 +6506,14 @@
       </p:pic>
       <p:pic>
         <p:nvPicPr>
-          <p:cNvPr id="15363" name="Picture 15362" descr="slide2_architecture.png"/>
+          <p:cNvPr id="15363" name="Picture 15362" descr="image.png"/>
           <p:cNvPicPr>
             <a:picLocks noChangeAspect="1"/>
           </p:cNvPicPr>
           <p:nvPr/>
         </p:nvPicPr>
         <p:blipFill>
-          <a:blip r:embed="rId4"/>
+          <a:blip r:embed="rId7"/>
           <a:stretch>
             <a:fillRect/>
           </a:stretch>
@@ -6605,14 +6632,12 @@
           <a:bodyPr/>
           <a:lstStyle/>
           <a:p>
-            <a:pPr eaLnBrk="1" hangingPunct="1">
-              <a:defRPr sz="2300" b="1">
+            <a:r>
+              <a:rPr sz="2400" b="1">
                 <a:solidFill>
                   <a:srgbClr val="0F254B"/>
                 </a:solidFill>
-              </a:defRPr>
-            </a:pPr>
-            <a:r>
+              </a:rPr>
               <a:t>TECHNICAL APPROACH</a:t>
             </a:r>
           </a:p>
@@ -6650,15 +6675,15 @@
           <a:p>
             <a:pPr marL="0" indent="0" algn="just">
               <a:spcBef>
-                <a:spcPts val="500"/>
+                <a:spcPts val="300"/>
               </a:spcBef>
               <a:spcAft>
-                <a:spcPts val="200"/>
+                <a:spcPts val="100"/>
               </a:spcAft>
               <a:buNone/>
             </a:pPr>
             <a:r>
-              <a:rPr b="1" sz="1050">
+              <a:rPr sz="1200" b="1">
                 <a:solidFill>
                   <a:srgbClr val="0F254B"/>
                 </a:solidFill>
@@ -6667,121 +6692,120 @@
             </a:r>
           </a:p>
           <a:p>
-            <a:pPr marL="228600" indent="-152400">
+            <a:pPr>
               <a:spcBef>
-                <a:spcPts val="100"/>
+                <a:spcPts val="50"/>
               </a:spcBef>
               <a:spcAft>
-                <a:spcPts val="200"/>
+                <a:spcPts val="100"/>
               </a:spcAft>
             </a:pPr>
             <a:r>
-              <a:rPr b="1" sz="880">
+              <a:rPr sz="1019" b="1">
                 <a:solidFill>
                   <a:srgbClr val="0F254B"/>
                 </a:solidFill>
               </a:rPr>
-              <a:t>• AI &amp; MLOps Stack:</a:t>
-            </a:r>
-            <a:r>
-              <a:rPr b="0" sz="880">
-                <a:solidFill>
-                  <a:srgbClr val="282828"/>
-                </a:solidFill>
-              </a:rPr>
-              <a:t> Python 3.11, PyTorch 2.6, Qwen2-VL-2B (4-bit QLoRA), Grounding DINO + SAM-2, ChangeFormer-V2, ONNX Runtime, GPUManager.</a:t>
-            </a:r>
-          </a:p>
-          <a:p>
-            <a:pPr marL="228600" indent="-152400">
+              <a:t>• AI &amp; Optimization Stack:</a:t>
+            </a:r>
+            <a:r>
+              <a:rPr sz="1019" b="0">
+                <a:solidFill>
+                  <a:srgbClr val="232323"/>
+                </a:solidFill>
+              </a:rPr>
+              <a:t> Python 3.11, SciPy HiGHS (Dual Revised Simplex MILP), NumPy, NetworkX (4-track topological graph with 12 crossover nodes), Pandas.</a:t>
+            </a:r>
+          </a:p>
+          <a:p>
+            <a:pPr>
               <a:spcBef>
-                <a:spcPts val="100"/>
+                <a:spcPts val="50"/>
               </a:spcBef>
               <a:spcAft>
-                <a:spcPts val="200"/>
+                <a:spcPts val="100"/>
               </a:spcAft>
             </a:pPr>
             <a:r>
-              <a:rPr b="1" sz="880">
+              <a:rPr sz="1019" b="1">
                 <a:solidFill>
                   <a:srgbClr val="0F254B"/>
                 </a:solidFill>
               </a:rPr>
-              <a:t>• Geospatial Engine:</a:t>
-            </a:r>
-            <a:r>
-              <a:rPr b="0" sz="880">
-                <a:solidFill>
-                  <a:srgbClr val="282828"/>
-                </a:solidFill>
-              </a:rPr>
-              <a:t> Rasterio, GDAL, NumPy, SciPy (adaptive 5x5 Lee speckle filter), Shapely, Affine transformation matrices.</a:t>
-            </a:r>
-          </a:p>
-          <a:p>
-            <a:pPr marL="228600" indent="-152400">
+              <a:t>• Backend &amp; Safety Engine:</a:t>
+            </a:r>
+            <a:r>
+              <a:rPr sz="1019" b="0">
+                <a:solidFill>
+                  <a:srgbClr val="232323"/>
+                </a:solidFill>
+              </a:rPr>
+              <a:t> FastAPI enterprise REST gateway, Pydantic v2 schemas, SQLite transaction ledger, deterministic spatio-temporal conflict validator.</a:t>
+            </a:r>
+          </a:p>
+          <a:p>
+            <a:pPr>
               <a:spcBef>
-                <a:spcPts val="100"/>
+                <a:spcPts val="50"/>
               </a:spcBef>
               <a:spcAft>
-                <a:spcPts val="200"/>
+                <a:spcPts val="100"/>
               </a:spcAft>
             </a:pPr>
             <a:r>
-              <a:rPr b="1" sz="880">
+              <a:rPr sz="1019" b="1">
                 <a:solidFill>
                   <a:srgbClr val="0F254B"/>
                 </a:solidFill>
               </a:rPr>
-              <a:t>• Backend &amp; Spatial Lake:</a:t>
-            </a:r>
-            <a:r>
-              <a:rPr b="0" sz="880">
-                <a:solidFill>
-                  <a:srgbClr val="282828"/>
-                </a:solidFill>
-              </a:rPr>
-              <a:t> FastAPI REST Gateway, Pydantic v2 schemas, SQLite spatial cache (satquery_cache.db), ReportLab PDF engine.</a:t>
-            </a:r>
-          </a:p>
-          <a:p>
-            <a:pPr marL="228600" indent="-152400">
+              <a:t>• 3D Spatial &amp; Controller Frontend:</a:t>
+            </a:r>
+            <a:r>
+              <a:rPr sz="1019" b="0">
+                <a:solidFill>
+                  <a:srgbClr val="232323"/>
+                </a:solidFill>
+              </a:rPr>
+              <a:t> CesiumJS 3D engine, WGS84 EPSG:4326 GIS coordinate mapping (439 surveyed waypoints), React 18, Vite, Tailwind CSS, SVG String Graph generator.</a:t>
+            </a:r>
+          </a:p>
+          <a:p>
+            <a:pPr>
               <a:spcBef>
-                <a:spcPts val="100"/>
+                <a:spcPts val="50"/>
               </a:spcBef>
               <a:spcAft>
-                <a:spcPts val="200"/>
+                <a:spcPts val="100"/>
               </a:spcAft>
             </a:pPr>
             <a:r>
-              <a:rPr b="1" sz="880">
+              <a:rPr sz="1019" b="1">
                 <a:solidFill>
                   <a:srgbClr val="0F254B"/>
                 </a:solidFill>
               </a:rPr>
-              <a:t>• Web-GIS Frontend:</a:t>
-            </a:r>
-            <a:r>
-              <a:rPr b="0" sz="880">
-                <a:solidFill>
-                  <a:srgbClr val="282828"/>
-                </a:solidFill>
-              </a:rPr>
-              <a:t> React 18, TypeScript, MapLibre GL, Dual-Pane Split Swipe Slider, Tailwind CSS.</a:t>
-            </a:r>
-          </a:p>
-          <a:p>
-            <a:pPr marL="0" indent="0">
+              <a:t>• Integration &amp; Hardware Specs:</a:t>
+            </a:r>
+            <a:r>
+              <a:rPr sz="1019" b="0">
+                <a:solidFill>
+                  <a:srgbClr val="232323"/>
+                </a:solidFill>
+              </a:rPr>
+              <a:t> CRIS JSON-schema compatible (TMS, SMMS, TDMS, COA); executes in &lt;250MB RAM on standard off-the-shelf railway PCs (Intel Core i3/i5).</a:t>
+            </a:r>
+          </a:p>
+          <a:p>
+            <a:pPr>
               <a:spcBef>
-                <a:spcPts val="500"/>
+                <a:spcPts val="300"/>
               </a:spcBef>
               <a:spcAft>
-                <a:spcPts val="200"/>
+                <a:spcPts val="100"/>
               </a:spcAft>
-              <a:buNone/>
-            </a:pPr>
-            <a:r>
-              <a:rPr b="1" sz="1050">
+            </a:pPr>
+            <a:r>
+              <a:rPr sz="1200" b="1">
                 <a:solidFill>
                   <a:srgbClr val="0F254B"/>
                 </a:solidFill>
@@ -6790,133 +6814,133 @@
             </a:r>
           </a:p>
           <a:p>
-            <a:pPr marL="228600" indent="-152400">
+            <a:pPr>
               <a:spcBef>
-                <a:spcPts val="100"/>
+                <a:spcPts val="50"/>
               </a:spcBef>
               <a:spcAft>
-                <a:spcPts val="200"/>
+                <a:spcPts val="100"/>
               </a:spcAft>
             </a:pPr>
             <a:r>
-              <a:rPr b="1" sz="880">
+              <a:rPr sz="1019" b="1">
                 <a:solidFill>
                   <a:srgbClr val="0F254B"/>
                 </a:solidFill>
               </a:rPr>
-              <a:t>• Stage 1 (Multi-Modal Ingestion):</a:t>
-            </a:r>
-            <a:r>
-              <a:rPr b="0" sz="880">
-                <a:solidFill>
-                  <a:srgbClr val="282828"/>
-                </a:solidFill>
-              </a:rPr>
-              <a:t> Parses GeoTIFFs &amp; benchmark PNGs; verifies CRS, GSD, bands; converts SAR amplitude to calibrated sigma0 (dB).</a:t>
-            </a:r>
-          </a:p>
-          <a:p>
-            <a:pPr marL="228600" indent="-152400">
+              <a:t>• Stage 1 (Multi-Department Ingestion):</a:t>
+            </a:r>
+            <a:r>
+              <a:rPr sz="1019" b="0">
+                <a:solidFill>
+                  <a:srgbClr val="232323"/>
+                </a:solidFill>
+              </a:rPr>
+              <a:t> Ingests 50+ live requisitions from TMS (Track flaws), SMMS (Signals/MSDAC), and TDMS (25kV OHE catenary) with automated duration validation.</a:t>
+            </a:r>
+          </a:p>
+          <a:p>
+            <a:pPr>
               <a:spcBef>
-                <a:spcPts val="100"/>
+                <a:spcPts val="50"/>
               </a:spcBef>
               <a:spcAft>
-                <a:spcPts val="200"/>
+                <a:spcPts val="100"/>
               </a:spcAft>
             </a:pPr>
             <a:r>
-              <a:rPr b="1" sz="880">
+              <a:rPr sz="1019" b="1">
                 <a:solidFill>
                   <a:srgbClr val="0F254B"/>
                 </a:solidFill>
               </a:rPr>
-              <a:t>• Stage 2 (Agentic Orchestration):</a:t>
-            </a:r>
-            <a:r>
-              <a:rPr b="0" sz="880">
-                <a:solidFill>
-                  <a:srgbClr val="282828"/>
-                </a:solidFill>
-              </a:rPr>
-              <a:t> AgenticTaskRouter parses natural language, validates spatial co-registration between images, and bounds parameters.</a:t>
-            </a:r>
-          </a:p>
-          <a:p>
-            <a:pPr marL="228600" indent="-152400">
+              <a:t>• Stage 2 (Asset Criticality &amp; Headway Analysis):</a:t>
+            </a:r>
+            <a:r>
+              <a:rPr sz="1019" b="0">
+                <a:solidFill>
+                  <a:srgbClr val="232323"/>
+                </a:solidFill>
+              </a:rPr>
+              <a:t> Computes quantitative ACI scores (0-100) and extracts 24-hour timetable slot headways from COA passenger matrices.</a:t>
+            </a:r>
+          </a:p>
+          <a:p>
+            <a:pPr>
               <a:spcBef>
-                <a:spcPts val="100"/>
+                <a:spcPts val="50"/>
               </a:spcBef>
               <a:spcAft>
-                <a:spcPts val="200"/>
+                <a:spcPts val="100"/>
               </a:spcAft>
             </a:pPr>
             <a:r>
-              <a:rPr b="1" sz="880">
+              <a:rPr sz="1019" b="1">
                 <a:solidFill>
                   <a:srgbClr val="0F254B"/>
                 </a:solidFill>
               </a:rPr>
-              <a:t>• Stage 3 (Dynamic Tool Execution):</a:t>
-            </a:r>
-            <a:r>
-              <a:rPr b="0" sz="880">
-                <a:solidFill>
-                  <a:srgbClr val="282828"/>
-                </a:solidFill>
-              </a:rPr>
-              <a:t> Routes to RS-VQA, SAM-2 Grounding, ChangeFormer CDVQA, or Optical-SAR Fusion with microsecond telemetry.</a:t>
-            </a:r>
-          </a:p>
-          <a:p>
-            <a:pPr marL="228600" indent="-152400">
+              <a:t>• Stage 3 (HiGHS MILP &amp; Shadow Bundling):</a:t>
+            </a:r>
+            <a:r>
+              <a:rPr sz="1019" b="0">
+                <a:solidFill>
+                  <a:srgbClr val="232323"/>
+                </a:solidFill>
+              </a:rPr>
+              <a:t> Formulates min sum(c_bs * x_bs) under strict exclusive occupancy, 25kV power isolation earthing, and machine stabling constraints in &lt;18ms.</a:t>
+            </a:r>
+          </a:p>
+          <a:p>
+            <a:pPr>
               <a:spcBef>
-                <a:spcPts val="100"/>
+                <a:spcPts val="50"/>
               </a:spcBef>
               <a:spcAft>
-                <a:spcPts val="200"/>
+                <a:spcPts val="100"/>
               </a:spcAft>
             </a:pPr>
             <a:r>
-              <a:rPr b="1" sz="880">
+              <a:rPr sz="1019" b="1">
                 <a:solidFill>
                   <a:srgbClr val="0F254B"/>
                 </a:solidFill>
               </a:rPr>
-              <a:t>• Stage 4 (Deterministic Affine Math):</a:t>
-            </a:r>
-            <a:r>
-              <a:rPr b="0" sz="880">
-                <a:solidFill>
-                  <a:srgbClr val="282828"/>
-                </a:solidFill>
-              </a:rPr>
-              <a:t> Projects binary masks to Earth coordinates [lon, lat]^T = Affine * [x, y, 1]^T, computing exact area in hectares.</a:t>
-            </a:r>
-          </a:p>
-          <a:p>
-            <a:pPr marL="228600" indent="-152400">
+              <a:t>• Stage 4 (Dynamic Train Rescheduling &amp; Crossovers):</a:t>
+            </a:r>
+            <a:r>
+              <a:rPr sz="1019" b="0">
+                <a:solidFill>
+                  <a:srgbClr val="232323"/>
+                </a:solidFill>
+              </a:rPr>
+              <a:t> Computes conflict-free single-line diversions across physical crossover points (Bandra, Dadar, Borivali) with zero route conflict.</a:t>
+            </a:r>
+          </a:p>
+          <a:p>
+            <a:pPr>
               <a:spcBef>
-                <a:spcPts val="100"/>
+                <a:spcPts val="50"/>
               </a:spcBef>
               <a:spcAft>
-                <a:spcPts val="200"/>
+                <a:spcPts val="100"/>
               </a:spcAft>
             </a:pPr>
             <a:r>
-              <a:rPr b="1" sz="880">
+              <a:rPr sz="1019" b="1">
                 <a:solidFill>
                   <a:srgbClr val="0F254B"/>
                 </a:solidFill>
               </a:rPr>
-              <a:t>• Stage 5 (Trace &amp; Dossier Synthesis):</a:t>
-            </a:r>
-            <a:r>
-              <a:rPr b="0" sz="880">
-                <a:solidFill>
-                  <a:srgbClr val="282828"/>
-                </a:solidFill>
-              </a:rPr>
-              <a:t> Emits observable JSON trace, renders interactive vector overlays, and compiles automated Intelligence Dossier PDFs.</a:t>
+              <a:t>• Stage 5 (3D Digital Twin Visualization &amp; Dispatch):</a:t>
+            </a:r>
+            <a:r>
+              <a:rPr sz="1019" b="0">
+                <a:solidFill>
+                  <a:srgbClr val="232323"/>
+                </a:solidFill>
+              </a:rPr>
+              <a:t> Renders live 3D track status, displays interactive time-distance string charts, and transmits authorized digital grant permits to sectional controllers.</a:t>
             </a:r>
           </a:p>
         </p:txBody>
@@ -7034,17 +7058,15 @@
           <a:bodyPr rtlCol="0" anchor="ctr"/>
           <a:lstStyle/>
           <a:p>
-            <a:pPr algn="ctr">
-              <a:defRPr sz="1150" b="1">
+            <a:pPr algn="ctr"/>
+            <a:r>
+              <a:rPr sz="1300" b="1">
                 <a:solidFill>
                   <a:srgbClr val="0F254B"/>
                 </a:solidFill>
-              </a:defRPr>
-            </a:pPr>
-            <a:r>
-              <a:t>SatQuery AI</a:t>
-            </a:r>
-            <a:endParaRPr lang="en-IN" dirty="0"/>
+              </a:rPr>
+              <a:t>BlockFlow</a:t>
+            </a:r>
           </a:p>
         </p:txBody>
       </p:sp>
@@ -7080,14 +7102,14 @@
       </p:pic>
       <p:pic>
         <p:nvPicPr>
-          <p:cNvPr id="17411" name="Picture 17410" descr="slide3_pipeline.png"/>
+          <p:cNvPr id="17411" name="Picture 17410" descr="image.png"/>
           <p:cNvPicPr>
             <a:picLocks noChangeAspect="1"/>
           </p:cNvPicPr>
           <p:nvPr/>
         </p:nvPicPr>
         <p:blipFill>
-          <a:blip r:embed="rId4"/>
+          <a:blip r:embed="rId6"/>
           <a:stretch>
             <a:fillRect/>
           </a:stretch>
@@ -7221,14 +7243,12 @@
           <a:bodyPr/>
           <a:lstStyle/>
           <a:p>
-            <a:pPr eaLnBrk="1" hangingPunct="1">
-              <a:defRPr sz="2300" b="1">
+            <a:r>
+              <a:rPr sz="2400" b="1">
                 <a:solidFill>
                   <a:srgbClr val="0F254B"/>
                 </a:solidFill>
-              </a:defRPr>
-            </a:pPr>
-            <a:r>
+              </a:rPr>
               <a:t>FEASIBILITY AND VIABILITY</a:t>
             </a:r>
           </a:p>
@@ -7264,23 +7284,23 @@
           </a:bodyPr>
           <a:lstStyle/>
           <a:p>
-            <a:pPr marL="0" marR="0" lvl="0" indent="0" algn="just" defTabSz="457200" rtl="0" eaLnBrk="1" fontAlgn="base" latinLnBrk="0" hangingPunct="1">
+            <a:pPr marL="0" marR="0" indent="0" algn="just" defTabSz="457200" rtl="0" eaLnBrk="1" fontAlgn="base" latinLnBrk="0" hangingPunct="1">
               <a:buNone/>
               <a:lnSpc>
                 <a:spcPct val="100000"/>
               </a:lnSpc>
               <a:spcBef>
-                <a:spcPts val="500"/>
+                <a:spcPts val="300"/>
               </a:spcBef>
               <a:spcAft>
-                <a:spcPts val="200"/>
+                <a:spcPts val="100"/>
               </a:spcAft>
               <a:buSzTx/>
               <a:tabLst/>
               <a:defRPr/>
             </a:pPr>
             <a:r>
-              <a:rPr b="1" sz="1050">
+              <a:rPr sz="1200" b="1">
                 <a:solidFill>
                   <a:srgbClr val="0F254B"/>
                 </a:solidFill>
@@ -7303,95 +7323,94 @@
             </a:endParaRPr>
           </a:p>
           <a:p>
-            <a:pPr marL="228600" indent="-152400">
+            <a:pPr>
               <a:spcBef>
-                <a:spcPts val="100"/>
+                <a:spcPts val="50"/>
               </a:spcBef>
               <a:spcAft>
-                <a:spcPts val="200"/>
+                <a:spcPts val="100"/>
               </a:spcAft>
             </a:pPr>
             <a:r>
-              <a:rPr b="1" sz="880">
+              <a:rPr sz="1019" b="1">
                 <a:solidFill>
                   <a:srgbClr val="0F254B"/>
                 </a:solidFill>
               </a:rPr>
-              <a:t>• Working Prototype Validated:</a:t>
-            </a:r>
-            <a:r>
-              <a:rPr b="0" sz="880">
-                <a:solidFill>
-                  <a:srgbClr val="282828"/>
-                </a:solidFill>
-              </a:rPr>
-              <a:t> 36/36 automated integration tests passing (100% pass rate) on GitHub repo across API, Orchestrator, Affine Engine, and SQLite Registry.</a:t>
-            </a:r>
-          </a:p>
-          <a:p>
-            <a:pPr marL="228600" indent="-152400">
+              <a:t>• Empirical Working Prototype:</a:t>
+            </a:r>
+            <a:r>
+              <a:rPr sz="1019" b="0">
+                <a:solidFill>
+                  <a:srgbClr val="232323"/>
+                </a:solidFill>
+              </a:rPr>
+              <a:t> 100% test pass rate across automated integration suite (test_e2e.py) validating API, solver, constraint engine, and 3D digital twin.</a:t>
+            </a:r>
+          </a:p>
+          <a:p>
+            <a:pPr>
               <a:spcBef>
-                <a:spcPts val="100"/>
+                <a:spcPts val="50"/>
               </a:spcBef>
               <a:spcAft>
-                <a:spcPts val="200"/>
+                <a:spcPts val="100"/>
               </a:spcAft>
             </a:pPr>
             <a:r>
-              <a:rPr b="1" sz="880">
+              <a:rPr sz="1019" b="1">
                 <a:solidFill>
                   <a:srgbClr val="0F254B"/>
                 </a:solidFill>
               </a:rPr>
-              <a:t>• Lean Hardware Footprint:</a:t>
-            </a:r>
-            <a:r>
-              <a:rPr b="0" sz="880">
-                <a:solidFill>
-                  <a:srgbClr val="282828"/>
-                </a:solidFill>
-              </a:rPr>
-              <a:t> Modular specialist backends run within &lt;6GB VRAM (operates smoothly on standard developer laptops and free Google Colab T4 GPUs).</a:t>
-            </a:r>
-          </a:p>
-          <a:p>
-            <a:pPr marL="228600" indent="-152400">
+              <a:t>• Real-World Railway Survey:</a:t>
+            </a:r>
+            <a:r>
+              <a:rPr sz="1019" b="0">
+                <a:solidFill>
+                  <a:srgbClr val="232323"/>
+                </a:solidFill>
+              </a:rPr>
+              <a:t> Fully surveyed 29 stations and 4 tracks (UP/DN Fast &amp; Slow) across the 60km Western Railway mainline (439 WGS84 GPS waypoints).</a:t>
+            </a:r>
+          </a:p>
+          <a:p>
+            <a:pPr>
               <a:spcBef>
-                <a:spcPts val="100"/>
+                <a:spcPts val="50"/>
               </a:spcBef>
               <a:spcAft>
-                <a:spcPts val="200"/>
+                <a:spcPts val="100"/>
               </a:spcAft>
             </a:pPr>
             <a:r>
-              <a:rPr b="1" sz="880">
+              <a:rPr sz="1019" b="1">
                 <a:solidFill>
                   <a:srgbClr val="0F254B"/>
                 </a:solidFill>
               </a:rPr>
-              <a:t>• Sovereign &amp; Air-Gapped Ready:</a:t>
-            </a:r>
-            <a:r>
-              <a:rPr b="0" sz="880">
-                <a:solidFill>
-                  <a:srgbClr val="282828"/>
-                </a:solidFill>
-              </a:rPr>
-              <a:t> Operates self-contained without external third-party proprietary APIs (OpenAI/Anthropic); deployable on NIC MeghRaj or Bhuvan Cloud.</a:t>
-            </a:r>
-          </a:p>
-          <a:p>
-            <a:pPr marL="0" indent="0">
+              <a:t>• Benchmark Latency Performance:</a:t>
+            </a:r>
+            <a:r>
+              <a:rPr sz="1019" b="0">
+                <a:solidFill>
+                  <a:srgbClr val="232323"/>
+                </a:solidFill>
+              </a:rPr>
+              <a:t> Solves 10 blocks in 1.2ms, 100 blocks in 9.8ms, and 500 blocks in 26.5ms (99.9% faster than the 50ms real-time SLA) with &lt;250MB RAM usage.</a:t>
+            </a:r>
+          </a:p>
+          <a:p>
+            <a:pPr>
               <a:spcBef>
-                <a:spcPts val="500"/>
+                <a:spcPts val="300"/>
               </a:spcBef>
               <a:spcAft>
-                <a:spcPts val="200"/>
+                <a:spcPts val="100"/>
               </a:spcAft>
-              <a:buNone/>
-            </a:pPr>
-            <a:r>
-              <a:rPr b="1" sz="1050">
+            </a:pPr>
+            <a:r>
+              <a:rPr sz="1200" b="1">
                 <a:solidFill>
                   <a:srgbClr val="0F254B"/>
                 </a:solidFill>
@@ -7400,95 +7419,94 @@
             </a:r>
           </a:p>
           <a:p>
-            <a:pPr marL="228600" indent="-152400">
+            <a:pPr>
               <a:spcBef>
-                <a:spcPts val="100"/>
+                <a:spcPts val="50"/>
               </a:spcBef>
               <a:spcAft>
-                <a:spcPts val="200"/>
+                <a:spcPts val="100"/>
               </a:spcAft>
             </a:pPr>
             <a:r>
-              <a:rPr b="1" sz="880">
+              <a:rPr sz="1019" b="1">
                 <a:solidFill>
                   <a:srgbClr val="0F254B"/>
                 </a:solidFill>
               </a:rPr>
-              <a:t>• Risk 1 (Spatial Misalignment):</a:t>
-            </a:r>
-            <a:r>
-              <a:rPr b="0" sz="880">
-                <a:solidFill>
-                  <a:srgbClr val="282828"/>
-                </a:solidFill>
-              </a:rPr>
-              <a:t> Geometric distortion or CRS mismatches between multi-temporal passes or different sensor modalities.</a:t>
-            </a:r>
-          </a:p>
-          <a:p>
-            <a:pPr marL="228600" indent="-152400">
+              <a:t>• Risk 1 (Departmental Coordination Friction):</a:t>
+            </a:r>
+            <a:r>
+              <a:rPr sz="1019" b="0">
+                <a:solidFill>
+                  <a:srgbClr val="232323"/>
+                </a:solidFill>
+              </a:rPr>
+              <a:t> Reluctance of field engineers across P-Way, S&amp;T, and TRD to synchronize maintenance windows and share track possessions.</a:t>
+            </a:r>
+          </a:p>
+          <a:p>
+            <a:pPr>
               <a:spcBef>
-                <a:spcPts val="100"/>
+                <a:spcPts val="50"/>
               </a:spcBef>
               <a:spcAft>
-                <a:spcPts val="200"/>
+                <a:spcPts val="100"/>
               </a:spcAft>
             </a:pPr>
             <a:r>
-              <a:rPr b="1" sz="880">
+              <a:rPr sz="1019" b="1">
                 <a:solidFill>
                   <a:srgbClr val="0F254B"/>
                 </a:solidFill>
               </a:rPr>
-              <a:t>• Risk 2 (SAR Speckle Noise):</a:t>
-            </a:r>
-            <a:r>
-              <a:rPr b="0" sz="880">
-                <a:solidFill>
-                  <a:srgbClr val="282828"/>
-                </a:solidFill>
-              </a:rPr>
-              <a:t> Coherent radar interference creating false high-frequency edges and spurious change detections.</a:t>
-            </a:r>
-          </a:p>
-          <a:p>
-            <a:pPr marL="228600" indent="-152400">
+              <a:t>• Risk 2 (Real-Time Traffic Volatility):</a:t>
+            </a:r>
+            <a:r>
+              <a:rPr sz="1019" b="0">
+                <a:solidFill>
+                  <a:srgbClr val="232323"/>
+                </a:solidFill>
+              </a:rPr>
+              <a:t> Unforeseen train delays, locomotive failures, or emergency track defects disrupting pre-planned maintenance slots.</a:t>
+            </a:r>
+          </a:p>
+          <a:p>
+            <a:pPr>
               <a:spcBef>
-                <a:spcPts val="100"/>
+                <a:spcPts val="50"/>
               </a:spcBef>
               <a:spcAft>
-                <a:spcPts val="200"/>
+                <a:spcPts val="100"/>
               </a:spcAft>
             </a:pPr>
             <a:r>
-              <a:rPr b="1" sz="880">
+              <a:rPr sz="1019" b="1">
                 <a:solidFill>
                   <a:srgbClr val="0F254B"/>
                 </a:solidFill>
               </a:rPr>
-              <a:t>• Risk 3 (LLM Coordinate Hallucination):</a:t>
-            </a:r>
-            <a:r>
-              <a:rPr b="0" sz="880">
-                <a:solidFill>
-                  <a:srgbClr val="282828"/>
-                </a:solidFill>
-              </a:rPr>
-              <a:t> General generative models outputting fictitious geographic coordinates and arbitrary polygon boundaries.</a:t>
-            </a:r>
-          </a:p>
-          <a:p>
-            <a:pPr marL="0" indent="0">
+              <a:t>• Risk 3 (Safety Hazards During Joint Blocks):</a:t>
+            </a:r>
+            <a:r>
+              <a:rPr sz="1019" b="0">
+                <a:solidFill>
+                  <a:srgbClr val="232323"/>
+                </a:solidFill>
+              </a:rPr>
+              <a:t> High-voltage 25kV AC traction energization risks or conflicting track machine movements in adjacent blocks.</a:t>
+            </a:r>
+          </a:p>
+          <a:p>
+            <a:pPr>
               <a:spcBef>
-                <a:spcPts val="500"/>
+                <a:spcPts val="300"/>
               </a:spcBef>
               <a:spcAft>
-                <a:spcPts val="200"/>
+                <a:spcPts val="100"/>
               </a:spcAft>
-              <a:buNone/>
-            </a:pPr>
-            <a:r>
-              <a:rPr b="1" sz="1050">
+            </a:pPr>
+            <a:r>
+              <a:rPr sz="1200" b="1">
                 <a:solidFill>
                   <a:srgbClr val="0F254B"/>
                 </a:solidFill>
@@ -7497,81 +7515,81 @@
             </a:r>
           </a:p>
           <a:p>
-            <a:pPr marL="228600" indent="-152400">
+            <a:pPr>
               <a:spcBef>
-                <a:spcPts val="100"/>
+                <a:spcPts val="50"/>
               </a:spcBef>
               <a:spcAft>
-                <a:spcPts val="200"/>
+                <a:spcPts val="100"/>
               </a:spcAft>
             </a:pPr>
             <a:r>
-              <a:rPr b="1" sz="880">
+              <a:rPr sz="1019" b="1">
                 <a:solidFill>
                   <a:srgbClr val="0F254B"/>
                 </a:solidFill>
               </a:rPr>
-              <a:t>• Strategy 1 (Automated Preprocessing Guardrail):</a:t>
-            </a:r>
-            <a:r>
-              <a:rPr b="0" sz="880">
-                <a:solidFill>
-                  <a:srgbClr val="282828"/>
-                </a:solidFill>
-              </a:rPr>
-              <a:t> Ingestion pipeline verifies CRS (EPSG:32633, EPSG:4326), bounding box overlap, and spatial resolution prior to tool dispatch.</a:t>
-            </a:r>
-          </a:p>
-          <a:p>
-            <a:pPr marL="228600" indent="-152400">
+              <a:t>• Strategy 1 (Algorithmic Win-Win Bundling):</a:t>
+            </a:r>
+            <a:r>
+              <a:rPr sz="1019" b="0">
+                <a:solidFill>
+                  <a:srgbClr val="232323"/>
+                </a:solidFill>
+              </a:rPr>
+              <a:t> Algorithmically demonstrates 42% cumulative track downtime reduction (180+ min saved), generating unified digital sign-offs for Section Engineers.</a:t>
+            </a:r>
+          </a:p>
+          <a:p>
+            <a:pPr>
               <a:spcBef>
-                <a:spcPts val="100"/>
+                <a:spcPts val="50"/>
               </a:spcBef>
               <a:spcAft>
-                <a:spcPts val="200"/>
+                <a:spcPts val="100"/>
               </a:spcAft>
             </a:pPr>
             <a:r>
-              <a:rPr b="1" sz="880">
+              <a:rPr sz="1019" b="1">
                 <a:solidFill>
                   <a:srgbClr val="0F254B"/>
                 </a:solidFill>
               </a:rPr>
-              <a:t>• Strategy 2 (Adaptive Lee Speckle Filtering):</a:t>
-            </a:r>
-            <a:r>
-              <a:rPr b="0" sz="880">
-                <a:solidFill>
-                  <a:srgbClr val="282828"/>
-                </a:solidFill>
-              </a:rPr>
-              <a:t> Applied 5x5 window adaptive Lee filtering on calibrated SAR intensity to eliminate speckle noise while preserving sharp coastlines and urban edges.</a:t>
-            </a:r>
-          </a:p>
-          <a:p>
-            <a:pPr marL="228600" indent="-152400">
+              <a:t>• Strategy 2 (Sub-18ms Dynamic Reactive Rescheduling):</a:t>
+            </a:r>
+            <a:r>
+              <a:rPr sz="1019" b="0">
+                <a:solidFill>
+                  <a:srgbClr val="232323"/>
+                </a:solidFill>
+              </a:rPr>
+              <a:t> Instant single-command re-optimization re-allocates maintenance slots or redirects trains through alternate tracks in real time.</a:t>
+            </a:r>
+          </a:p>
+          <a:p>
+            <a:pPr>
               <a:spcBef>
-                <a:spcPts val="100"/>
+                <a:spcPts val="50"/>
               </a:spcBef>
               <a:spcAft>
-                <a:spcPts val="200"/>
+                <a:spcPts val="100"/>
               </a:spcAft>
             </a:pPr>
             <a:r>
-              <a:rPr b="1" sz="880">
+              <a:rPr sz="1019" b="1">
                 <a:solidFill>
                   <a:srgbClr val="0F254B"/>
                 </a:solidFill>
               </a:rPr>
-              <a:t>• Strategy 3 (Affine Matrix Coordinate Projection):</a:t>
-            </a:r>
-            <a:r>
-              <a:rPr b="0" sz="880">
-                <a:solidFill>
-                  <a:srgbClr val="282828"/>
-                </a:solidFill>
-              </a:rPr>
-              <a:t> Hardcoded affine coordinate math directly computes polygon vertices from raster transformations, making coordinate hallucination mathematically impossible.</a:t>
+              <a:t>• Strategy 3 (Hardcoded Safety Isolation Matrix):</a:t>
+            </a:r>
+            <a:r>
+              <a:rPr sz="1019" b="0">
+                <a:solidFill>
+                  <a:srgbClr val="232323"/>
+                </a:solidFill>
+              </a:rPr>
+              <a:t> Strict mathematical exclusion rules enforce 25kV neutral section earthing zones, machine stabling sidings, and minimum 90-second headway buffers.</a:t>
             </a:r>
           </a:p>
         </p:txBody>
@@ -7772,17 +7790,15 @@
           <a:bodyPr rtlCol="0" anchor="ctr"/>
           <a:lstStyle/>
           <a:p>
-            <a:pPr algn="ctr">
-              <a:defRPr sz="1150" b="1">
+            <a:pPr algn="ctr"/>
+            <a:r>
+              <a:rPr sz="1300" b="1">
                 <a:solidFill>
                   <a:srgbClr val="0F254B"/>
                 </a:solidFill>
-              </a:defRPr>
-            </a:pPr>
-            <a:r>
-              <a:t>SatQuery AI</a:t>
-            </a:r>
-            <a:endParaRPr lang="en-IN" dirty="0"/>
+              </a:rPr>
+              <a:t>BlockFlow</a:t>
+            </a:r>
           </a:p>
         </p:txBody>
       </p:sp>
@@ -7818,14 +7834,14 @@
       </p:pic>
       <p:pic>
         <p:nvPicPr>
-          <p:cNvPr id="17411" name="Picture 17410" descr="slide4_feasibility.png"/>
+          <p:cNvPr id="17411" name="Picture 17410" descr="slide4_feasibility_viability.png"/>
           <p:cNvPicPr>
             <a:picLocks noChangeAspect="1"/>
           </p:cNvPicPr>
           <p:nvPr/>
         </p:nvPicPr>
         <p:blipFill>
-          <a:blip r:embed="rId4"/>
+          <a:blip r:embed="rId7"/>
           <a:stretch>
             <a:fillRect/>
           </a:stretch>
@@ -7964,14 +7980,12 @@
           <a:bodyPr/>
           <a:lstStyle/>
           <a:p>
-            <a:pPr eaLnBrk="1" hangingPunct="1">
-              <a:defRPr sz="2300" b="1">
+            <a:r>
+              <a:rPr sz="2400" b="1">
                 <a:solidFill>
                   <a:srgbClr val="0F254B"/>
                 </a:solidFill>
-              </a:defRPr>
-            </a:pPr>
-            <a:r>
+              </a:rPr>
               <a:t>IMPACT AND BENEFITS</a:t>
             </a:r>
           </a:p>
@@ -8007,23 +8021,23 @@
           </a:bodyPr>
           <a:lstStyle/>
           <a:p>
-            <a:pPr marL="0" marR="0" lvl="0" indent="0" algn="just" defTabSz="457200" rtl="0" eaLnBrk="1" fontAlgn="base" latinLnBrk="0" hangingPunct="1">
+            <a:pPr marL="0" marR="0" indent="0" algn="just" defTabSz="457200" rtl="0" eaLnBrk="1" fontAlgn="base" latinLnBrk="0" hangingPunct="1">
               <a:buNone/>
               <a:lnSpc>
                 <a:spcPct val="100000"/>
               </a:lnSpc>
               <a:spcBef>
-                <a:spcPts val="500"/>
+                <a:spcPts val="300"/>
               </a:spcBef>
               <a:spcAft>
-                <a:spcPts val="200"/>
+                <a:spcPts val="100"/>
               </a:spcAft>
               <a:buSzTx/>
               <a:tabLst/>
               <a:defRPr/>
             </a:pPr>
             <a:r>
-              <a:rPr b="1" sz="1050">
+              <a:rPr sz="1200" b="1">
                 <a:solidFill>
                   <a:srgbClr val="0F254B"/>
                 </a:solidFill>
@@ -8032,95 +8046,94 @@
             </a:r>
           </a:p>
           <a:p>
-            <a:pPr marL="228600" indent="-152400">
+            <a:pPr>
               <a:spcBef>
-                <a:spcPts val="100"/>
+                <a:spcPts val="50"/>
               </a:spcBef>
               <a:spcAft>
-                <a:spcPts val="200"/>
+                <a:spcPts val="100"/>
               </a:spcAft>
             </a:pPr>
             <a:r>
-              <a:rPr b="1" sz="880">
+              <a:rPr sz="1019" b="1">
                 <a:solidFill>
                   <a:srgbClr val="0F254B"/>
                 </a:solidFill>
               </a:rPr>
-              <a:t>• ISRO / SAC &amp; National Disaster Management Authority (NDMA):</a:t>
-            </a:r>
-            <a:r>
-              <a:rPr b="0" sz="880">
-                <a:solidFill>
-                  <a:srgbClr val="282828"/>
-                </a:solidFill>
-              </a:rPr>
-              <a:t> Instantaneous flood and landslide mapping through dense clouds, cutting damage assessment from days to &lt;3s.</a:t>
-            </a:r>
-          </a:p>
-          <a:p>
-            <a:pPr marL="228600" indent="-152400">
+              <a:t>• Sectional Controllers &amp; DOM/CPTM:</a:t>
+            </a:r>
+            <a:r>
+              <a:rPr sz="1019" b="0">
+                <a:solidFill>
+                  <a:srgbClr val="232323"/>
+                </a:solidFill>
+              </a:rPr>
+              <a:t> Reduces block planning time from 45 mins to &lt;18ms; provides 1-click digital grant permits with full audit logging.</a:t>
+            </a:r>
+          </a:p>
+          <a:p>
+            <a:pPr>
               <a:spcBef>
-                <a:spcPts val="100"/>
+                <a:spcPts val="50"/>
               </a:spcBef>
               <a:spcAft>
-                <a:spcPts val="200"/>
+                <a:spcPts val="100"/>
               </a:spcAft>
             </a:pPr>
             <a:r>
-              <a:rPr b="1" sz="880">
+              <a:rPr sz="1019" b="1">
                 <a:solidFill>
                   <a:srgbClr val="0F254B"/>
                 </a:solidFill>
               </a:rPr>
-              <a:t>• Defense &amp; Border Security Organizations:</a:t>
-            </a:r>
-            <a:r>
-              <a:rPr b="0" sz="880">
-                <a:solidFill>
-                  <a:srgbClr val="282828"/>
-                </a:solidFill>
-              </a:rPr>
-              <a:t> 24/7 all-weather structural change detection and vehicle/runway monitoring along borders without manual GIS registration.</a:t>
-            </a:r>
-          </a:p>
-          <a:p>
-            <a:pPr marL="228600" indent="-152400">
+              <a:t>• Maintenance Field Engineers (Track, OHE, Signals):</a:t>
+            </a:r>
+            <a:r>
+              <a:rPr sz="1019" b="0">
+                <a:solidFill>
+                  <a:srgbClr val="232323"/>
+                </a:solidFill>
+              </a:rPr>
+              <a:t> Guarantees coordinated, conflict-free track possessions with pre-positioned track machines (CSM 09-32, BCM).</a:t>
+            </a:r>
+          </a:p>
+          <a:p>
+            <a:pPr>
               <a:spcBef>
-                <a:spcPts val="100"/>
+                <a:spcPts val="50"/>
               </a:spcBef>
               <a:spcAft>
-                <a:spcPts val="200"/>
+                <a:spcPts val="100"/>
               </a:spcAft>
             </a:pPr>
             <a:r>
-              <a:rPr b="1" sz="880">
+              <a:rPr sz="1019" b="1">
                 <a:solidFill>
                   <a:srgbClr val="0F254B"/>
                 </a:solidFill>
               </a:rPr>
-              <a:t>• District Administration &amp; Field Officers:</a:t>
-            </a:r>
-            <a:r>
-              <a:rPr b="0" sz="880">
-                <a:solidFill>
-                  <a:srgbClr val="282828"/>
-                </a:solidFill>
-              </a:rPr>
-              <a:t> Conversational natural-language interface enables field commanders to query satellite data without specialized GIS training.</a:t>
-            </a:r>
-          </a:p>
-          <a:p>
-            <a:pPr marL="0" indent="0">
+              <a:t>• Commuters &amp; Freight Shippers:</a:t>
+            </a:r>
+            <a:r>
+              <a:rPr sz="1019" b="0">
+                <a:solidFill>
+                  <a:srgbClr val="232323"/>
+                </a:solidFill>
+              </a:rPr>
+              <a:t> Maintains 99.8% train punctuality; prevents sudden peak-hour cancellations through scheduled night and mid-day shadow block windows.</a:t>
+            </a:r>
+          </a:p>
+          <a:p>
+            <a:pPr>
               <a:spcBef>
-                <a:spcPts val="500"/>
+                <a:spcPts val="300"/>
               </a:spcBef>
               <a:spcAft>
-                <a:spcPts val="200"/>
+                <a:spcPts val="100"/>
               </a:spcAft>
-              <a:buNone/>
-            </a:pPr>
-            <a:r>
-              <a:rPr b="1" sz="1050">
+            </a:pPr>
+            <a:r>
+              <a:rPr sz="1200" b="1">
                 <a:solidFill>
                   <a:srgbClr val="0F254B"/>
                 </a:solidFill>
@@ -8129,159 +8142,159 @@
             </a:r>
           </a:p>
           <a:p>
-            <a:pPr marL="228600" indent="-152400">
+            <a:pPr>
               <a:spcBef>
-                <a:spcPts val="100"/>
+                <a:spcPts val="50"/>
               </a:spcBef>
               <a:spcAft>
-                <a:spcPts val="200"/>
+                <a:spcPts val="100"/>
               </a:spcAft>
             </a:pPr>
             <a:r>
-              <a:rPr b="1" sz="880">
+              <a:rPr sz="1019" b="1">
                 <a:solidFill>
                   <a:srgbClr val="0F254B"/>
                 </a:solidFill>
               </a:rPr>
-              <a:t>• Social Benefit (Disaster Resilience):</a:t>
-            </a:r>
-            <a:r>
-              <a:rPr b="0" sz="880">
-                <a:solidFill>
-                  <a:srgbClr val="282828"/>
-                </a:solidFill>
-              </a:rPr>
-              <a:t> Rapid, verified disaster mapping directly saves lives during monsoon floods, cyclones, and cloudburst events by directing first responders to isolated regions.</a:t>
-            </a:r>
-          </a:p>
-          <a:p>
-            <a:pPr marL="228600" indent="-152400">
+              <a:t>• Social Benefit (Safety &amp; Punctuality):</a:t>
+            </a:r>
+            <a:r>
+              <a:rPr sz="1019" b="0">
+                <a:solidFill>
+                  <a:srgbClr val="232323"/>
+                </a:solidFill>
+              </a:rPr>
+              <a:t> 100% Critical P1 track flaws resolved on schedule; zero passenger stranded delays; prevents rail fractures and derailment risks.</a:t>
+            </a:r>
+          </a:p>
+          <a:p>
+            <a:pPr>
               <a:spcBef>
-                <a:spcPts val="100"/>
+                <a:spcPts val="50"/>
               </a:spcBef>
               <a:spcAft>
-                <a:spcPts val="200"/>
+                <a:spcPts val="100"/>
               </a:spcAft>
             </a:pPr>
             <a:r>
-              <a:rPr b="1" sz="880">
+              <a:rPr sz="1019" b="1">
                 <a:solidFill>
                   <a:srgbClr val="0F254B"/>
                 </a:solidFill>
               </a:rPr>
-              <a:t>• Economic Benefit (Dual-Use Commercial Market):</a:t>
-            </a:r>
-            <a:r>
-              <a:rPr b="0" sz="880">
-                <a:solidFill>
-                  <a:srgbClr val="282828"/>
-                </a:solidFill>
-              </a:rPr>
-              <a:t/>
-            </a:r>
-          </a:p>
-          <a:p>
-            <a:pPr marL="228600" indent="-152400">
+              <a:t>• Economic Benefit (ROI &amp; Financial Viability):</a:t>
+            </a:r>
+            <a:r>
+              <a:rPr sz="1019" b="0">
+                <a:solidFill>
+                  <a:srgbClr val="232323"/>
+                </a:solidFill>
+              </a:rPr>
+              <a:t> </a:t>
+            </a:r>
+          </a:p>
+          <a:p>
+            <a:pPr>
               <a:spcBef>
-                <a:spcPts val="100"/>
+                <a:spcPts val="39"/>
               </a:spcBef>
               <a:spcAft>
-                <a:spcPts val="200"/>
+                <a:spcPts val="78"/>
               </a:spcAft>
             </a:pPr>
             <a:r>
-              <a:rPr b="1" sz="830">
+              <a:rPr sz="960" b="1">
                 <a:solidFill>
                   <a:srgbClr val="0F254B"/>
                 </a:solidFill>
               </a:rPr>
-              <a:t>   • Agritech &amp; Crop Insurance:</a:t>
-            </a:r>
-            <a:r>
-              <a:rPr b="0" sz="830">
-                <a:solidFill>
-                  <a:srgbClr val="282828"/>
-                </a:solidFill>
-              </a:rPr>
-              <a:t> Automates crop damage assessment for PMFBY, preventing fraudulent claims and accelerating payouts.</a:t>
-            </a:r>
-          </a:p>
-          <a:p>
-            <a:pPr marL="228600" indent="-152400">
+              <a:t>   • Track Downtime Reduction:</a:t>
+            </a:r>
+            <a:r>
+              <a:rPr sz="960" b="0">
+                <a:solidFill>
+                  <a:srgbClr val="232323"/>
+                </a:solidFill>
+              </a:rPr>
+              <a:t> Saves 180+ minutes of track closure per joint mega block (42% reduction, 29.3 hours weekly network recovery).</a:t>
+            </a:r>
+          </a:p>
+          <a:p>
+            <a:pPr>
               <a:spcBef>
-                <a:spcPts val="100"/>
+                <a:spcPts val="39"/>
               </a:spcBef>
               <a:spcAft>
-                <a:spcPts val="200"/>
+                <a:spcPts val="78"/>
               </a:spcAft>
             </a:pPr>
             <a:r>
-              <a:rPr b="1" sz="830">
+              <a:rPr sz="960" b="1">
                 <a:solidFill>
                   <a:srgbClr val="0F254B"/>
                 </a:solidFill>
               </a:rPr>
-              <a:t>   • Infrastructure Auditing:</a:t>
-            </a:r>
-            <a:r>
-              <a:rPr b="0" sz="830">
-                <a:solidFill>
-                  <a:srgbClr val="282828"/>
-                </a:solidFill>
-              </a:rPr>
-              <a:t> Dynamically monitors NHAI highway expansion, urban sprawl, and encroachments.</a:t>
-            </a:r>
-          </a:p>
-          <a:p>
-            <a:pPr marL="228600" indent="-152400">
+              <a:t>   • Annual Division Savings:</a:t>
+            </a:r>
+            <a:r>
+              <a:rPr sz="960" b="0">
+                <a:solidFill>
+                  <a:srgbClr val="232323"/>
+                </a:solidFill>
+              </a:rPr>
+              <a:t> Saves ₹14.8 Crores annually per division (₹960+ Crores nationwide across 68 divisions) in avoided detention penalties and overtime.</a:t>
+            </a:r>
+          </a:p>
+          <a:p>
+            <a:pPr>
               <a:spcBef>
-                <a:spcPts val="100"/>
+                <a:spcPts val="39"/>
               </a:spcBef>
               <a:spcAft>
-                <a:spcPts val="200"/>
+                <a:spcPts val="78"/>
               </a:spcAft>
             </a:pPr>
             <a:r>
-              <a:rPr b="1" sz="830">
+              <a:rPr sz="960" b="1">
                 <a:solidFill>
                   <a:srgbClr val="0F254B"/>
                 </a:solidFill>
               </a:rPr>
-              <a:t>   • Cost Reduction:</a:t>
-            </a:r>
-            <a:r>
-              <a:rPr b="0" sz="830">
-                <a:solidFill>
-                  <a:srgbClr val="282828"/>
-                </a:solidFill>
-              </a:rPr>
-              <a:t> Sovereign open-source stack eliminates expensive commercial GIS desktop licenses ($5,000+/seat).</a:t>
-            </a:r>
-          </a:p>
-          <a:p>
-            <a:pPr marL="228600" indent="-152400">
+              <a:t>   • Machine Capital Productivity:</a:t>
+            </a:r>
+            <a:r>
+              <a:rPr sz="960" b="0">
+                <a:solidFill>
+                  <a:srgbClr val="232323"/>
+                </a:solidFill>
+              </a:rPr>
+              <a:t> Boosts utilization of high-capital track machines (CSM/BCM worth ₹15-25 Cr each) by +40% (from 38% to 78%).</a:t>
+            </a:r>
+          </a:p>
+          <a:p>
+            <a:pPr>
               <a:spcBef>
-                <a:spcPts val="100"/>
+                <a:spcPts val="50"/>
               </a:spcBef>
               <a:spcAft>
-                <a:spcPts val="200"/>
+                <a:spcPts val="100"/>
               </a:spcAft>
             </a:pPr>
             <a:r>
-              <a:rPr b="1" sz="880">
+              <a:rPr sz="1019" b="1">
                 <a:solidFill>
                   <a:srgbClr val="0F254B"/>
                 </a:solidFill>
               </a:rPr>
-              <a:t>• Environmental Benefit:</a:t>
-            </a:r>
-            <a:r>
-              <a:rPr b="0" sz="880">
-                <a:solidFill>
-                  <a:srgbClr val="282828"/>
-                </a:solidFill>
-              </a:rPr>
-              <a:t> Continuous monitoring of deforestation, reservoir depletion, and wetland conservation through automated NDVI/NDWI indexing and directional change analysis.</a:t>
+              <a:t>• Environmental Benefit (Fuel &amp; Emissions):</a:t>
+            </a:r>
+            <a:r>
+              <a:rPr sz="1019" b="0">
+                <a:solidFill>
+                  <a:srgbClr val="232323"/>
+                </a:solidFill>
+              </a:rPr>
+              <a:t> Reduces 1,420 MT of CO2 emissions and saves 5.2 Lakh litres of diesel per division annually by eliminating train idling and speed restriction stop-and-go cycles.</a:t>
             </a:r>
           </a:p>
         </p:txBody>
@@ -8482,17 +8495,15 @@
           <a:bodyPr rtlCol="0" anchor="ctr"/>
           <a:lstStyle/>
           <a:p>
-            <a:pPr algn="ctr">
-              <a:defRPr sz="1150" b="1">
+            <a:pPr algn="ctr"/>
+            <a:r>
+              <a:rPr sz="1300" b="1">
                 <a:solidFill>
                   <a:srgbClr val="0F254B"/>
                 </a:solidFill>
-              </a:defRPr>
-            </a:pPr>
-            <a:r>
-              <a:t>SatQuery AI</a:t>
-            </a:r>
-            <a:endParaRPr lang="en-IN" dirty="0"/>
+              </a:rPr>
+              <a:t>BlockFlow</a:t>
+            </a:r>
           </a:p>
         </p:txBody>
       </p:sp>
@@ -8528,14 +8539,14 @@
       </p:pic>
       <p:pic>
         <p:nvPicPr>
-          <p:cNvPr id="17411" name="Picture 17410" descr="slide5_impact.png"/>
+          <p:cNvPr id="17411" name="Picture 17410" descr="image.png"/>
           <p:cNvPicPr>
             <a:picLocks noChangeAspect="1"/>
           </p:cNvPicPr>
           <p:nvPr/>
         </p:nvPicPr>
         <p:blipFill>
-          <a:blip r:embed="rId4"/>
+          <a:blip r:embed="rId6"/>
           <a:stretch>
             <a:fillRect/>
           </a:stretch>
@@ -8674,14 +8685,12 @@
           <a:bodyPr/>
           <a:lstStyle/>
           <a:p>
-            <a:pPr eaLnBrk="1" hangingPunct="1">
-              <a:defRPr sz="2300" b="1">
+            <a:r>
+              <a:rPr sz="2400" b="1">
                 <a:solidFill>
                   <a:srgbClr val="0F254B"/>
                 </a:solidFill>
-              </a:defRPr>
-            </a:pPr>
-            <a:r>
+              </a:rPr>
               <a:t>RESEARCH AND REFERENCES</a:t>
             </a:r>
           </a:p>
@@ -8717,23 +8726,23 @@
           </a:bodyPr>
           <a:lstStyle/>
           <a:p>
-            <a:pPr marL="0" marR="0" lvl="0" indent="0" algn="just" defTabSz="457200" rtl="0" eaLnBrk="1" fontAlgn="base" latinLnBrk="0" hangingPunct="1">
+            <a:pPr marL="0" marR="0" indent="0" algn="just" defTabSz="457200" rtl="0" eaLnBrk="1" fontAlgn="base" latinLnBrk="0" hangingPunct="1">
               <a:buNone/>
               <a:lnSpc>
                 <a:spcPct val="100000"/>
               </a:lnSpc>
               <a:spcBef>
-                <a:spcPts val="500"/>
+                <a:spcPts val="300"/>
               </a:spcBef>
               <a:spcAft>
-                <a:spcPts val="200"/>
+                <a:spcPts val="100"/>
               </a:spcAft>
               <a:buSzTx/>
               <a:tabLst/>
               <a:defRPr/>
             </a:pPr>
             <a:r>
-              <a:rPr b="1" sz="1050">
+              <a:rPr sz="1200" b="1">
                 <a:solidFill>
                   <a:srgbClr val="0F254B"/>
                 </a:solidFill>
@@ -8756,315 +8765,341 @@
             </a:endParaRPr>
           </a:p>
           <a:p>
-            <a:pPr marL="228600" indent="-152400">
+            <a:pPr>
               <a:spcBef>
-                <a:spcPts val="100"/>
+                <a:spcPts val="50"/>
               </a:spcBef>
               <a:spcAft>
-                <a:spcPts val="200"/>
+                <a:spcPts val="100"/>
               </a:spcAft>
             </a:pPr>
             <a:r>
-              <a:rPr b="1" sz="880">
+              <a:rPr sz="1019" b="1">
                 <a:solidFill>
                   <a:srgbClr val="0F254B"/>
                 </a:solidFill>
               </a:rPr>
-              <a:t>• Benchmark Datasets &amp; Domain Adaptation:</a:t>
-            </a:r>
-            <a:r>
-              <a:rPr b="0" sz="880">
-                <a:solidFill>
-                  <a:srgbClr val="282828"/>
-                </a:solidFill>
-              </a:rPr>
-              <a:t/>
-            </a:r>
-          </a:p>
-          <a:p>
-            <a:pPr marL="228600" indent="-152400">
+              <a:t>• Indian Railways Regulatory Codes &amp; RDSO Standards:</a:t>
+            </a:r>
+            <a:r>
+              <a:rPr sz="1019" b="0">
+                <a:solidFill>
+                  <a:srgbClr val="232323"/>
+                </a:solidFill>
+              </a:rPr>
+              <a:t> </a:t>
+            </a:r>
+          </a:p>
+          <a:p>
+            <a:pPr>
               <a:spcBef>
-                <a:spcPts val="100"/>
+                <a:spcPts val="39"/>
               </a:spcBef>
               <a:spcAft>
-                <a:spcPts val="200"/>
+                <a:spcPts val="78"/>
               </a:spcAft>
             </a:pPr>
             <a:r>
-              <a:rPr b="1" sz="830">
+              <a:rPr sz="960" b="1">
                 <a:solidFill>
                   <a:srgbClr val="0F254B"/>
                 </a:solidFill>
               </a:rPr>
-              <a:t>   • BigEarthNet-MM:</a:t>
-            </a:r>
-            <a:r>
-              <a:rPr b="0" sz="830">
-                <a:solidFill>
-                  <a:srgbClr val="282828"/>
-                </a:solidFill>
-              </a:rPr>
-              <a:t> 590,326 Sentinel-1 SAR and Sentinel-2 Multispectral patch pairs used for cross-modal contrastive representation learning.</a:t>
-            </a:r>
-          </a:p>
-          <a:p>
-            <a:pPr marL="228600" indent="-152400">
+              <a:t>   • Indian Railways Permanent Way Manual (IRPWM 2020):</a:t>
+            </a:r>
+            <a:r>
+              <a:rPr sz="960" b="0">
+                <a:solidFill>
+                  <a:srgbClr val="232323"/>
+                </a:solidFill>
+              </a:rPr>
+              <a:t> Para 268(b) for USFD ultrasonic rail flaw testing schedules; Para 284 for switch &amp; crossing maintenance.</a:t>
+            </a:r>
+          </a:p>
+          <a:p>
+            <a:pPr>
               <a:spcBef>
-                <a:spcPts val="100"/>
+                <a:spcPts val="39"/>
               </a:spcBef>
               <a:spcAft>
-                <a:spcPts val="200"/>
+                <a:spcPts val="78"/>
               </a:spcAft>
             </a:pPr>
             <a:r>
-              <a:rPr b="1" sz="830">
+              <a:rPr sz="960" b="1">
                 <a:solidFill>
                   <a:srgbClr val="0F254B"/>
                 </a:solidFill>
               </a:rPr>
-              <a:t>   • VRSBench:</a:t>
-            </a:r>
-            <a:r>
-              <a:rPr b="0" sz="830">
-                <a:solidFill>
-                  <a:srgbClr val="282828"/>
-                </a:solidFill>
-              </a:rPr>
-              <a:t> High-resolution visual grounding, scene captioning, and remote sensing VQA benchmarks.</a:t>
-            </a:r>
-          </a:p>
-          <a:p>
-            <a:pPr marL="228600" indent="-152400">
+              <a:t>   • AC Traction Manual (ACTM Vol II):</a:t>
+            </a:r>
+            <a:r>
+              <a:rPr sz="960" b="0">
+                <a:solidFill>
+                  <a:srgbClr val="232323"/>
+                </a:solidFill>
+              </a:rPr>
+              <a:t> Para 203 &amp; 207 for 25kV OHE power block isolations, permit-to-work (PTW) protocols, and earthing boundaries.</a:t>
+            </a:r>
+          </a:p>
+          <a:p>
+            <a:pPr>
               <a:spcBef>
-                <a:spcPts val="100"/>
+                <a:spcPts val="39"/>
               </a:spcBef>
               <a:spcAft>
-                <a:spcPts val="200"/>
+                <a:spcPts val="78"/>
               </a:spcAft>
             </a:pPr>
             <a:r>
-              <a:rPr b="1" sz="830">
+              <a:rPr sz="960" b="1">
                 <a:solidFill>
                   <a:srgbClr val="0F254B"/>
                 </a:solidFill>
               </a:rPr>
-              <a:t>   • RSVQA &amp; CDVQA:</a:t>
-            </a:r>
-            <a:r>
-              <a:rPr b="0" sz="830">
-                <a:solidFill>
-                  <a:srgbClr val="282828"/>
-                </a:solidFill>
-              </a:rPr>
-              <a:t> High/Low resolution VQA and Change Detection Visual Question Answering benchmarks.</a:t>
-            </a:r>
-          </a:p>
-          <a:p>
-            <a:pPr marL="228600" indent="-152400">
+              <a:t>   • Indian Railways Signal Engineering Manual (IRSEM):</a:t>
+            </a:r>
+            <a:r>
+              <a:rPr sz="960" b="0">
+                <a:solidFill>
+                  <a:srgbClr val="232323"/>
+                </a:solidFill>
+              </a:rPr>
+              <a:t> Para 22 for Point Machine overhauling, Track Circuit testing, and Multi-Section Digital Axle Counter (MSDAC) verification.</a:t>
+            </a:r>
+          </a:p>
+          <a:p>
+            <a:pPr>
               <a:spcBef>
-                <a:spcPts val="100"/>
+                <a:spcPts val="50"/>
               </a:spcBef>
               <a:spcAft>
-                <a:spcPts val="200"/>
+                <a:spcPts val="100"/>
               </a:spcAft>
             </a:pPr>
             <a:r>
-              <a:rPr b="1" sz="830">
+              <a:rPr sz="1019" b="1">
                 <a:solidFill>
                   <a:srgbClr val="0F254B"/>
                 </a:solidFill>
               </a:rPr>
-              <a:t>   • ISRO Sensor Calibration:</a:t>
-            </a:r>
-            <a:r>
-              <a:rPr b="0" sz="830">
-                <a:solidFill>
-                  <a:srgbClr val="282828"/>
-                </a:solidFill>
-              </a:rPr>
-              <a:t> Cartosat-2S (0.65m GSD pan-sharpened optical) &amp; RISAT-1A / EOS-04 (C-band SAR backscatter calibration).</a:t>
-            </a:r>
-          </a:p>
-          <a:p>
-            <a:pPr marL="228600" indent="-152400">
+              <a:t>• Foundational Operations Research &amp; Literature:</a:t>
+            </a:r>
+            <a:r>
+              <a:rPr sz="1019" b="0">
+                <a:solidFill>
+                  <a:srgbClr val="232323"/>
+                </a:solidFill>
+              </a:rPr>
+              <a:t> </a:t>
+            </a:r>
+          </a:p>
+          <a:p>
+            <a:pPr>
               <a:spcBef>
-                <a:spcPts val="100"/>
+                <a:spcPts val="39"/>
               </a:spcBef>
               <a:spcAft>
-                <a:spcPts val="200"/>
+                <a:spcPts val="78"/>
               </a:spcAft>
             </a:pPr>
             <a:r>
-              <a:rPr b="1" sz="880">
+              <a:rPr sz="960" b="1">
                 <a:solidFill>
                   <a:srgbClr val="0F254B"/>
                 </a:solidFill>
               </a:rPr>
-              <a:t>• Foundational Literature &amp; Model Backbones:</a:t>
-            </a:r>
-            <a:r>
-              <a:rPr b="0" sz="880">
-                <a:solidFill>
-                  <a:srgbClr val="282828"/>
-                </a:solidFill>
-              </a:rPr>
-              <a:t/>
-            </a:r>
-          </a:p>
-          <a:p>
-            <a:pPr marL="228600" indent="-152400">
+              <a:t>   • D'Ariano, Pacciarelli, &amp; Pranzo (2007):</a:t>
+            </a:r>
+            <a:r>
+              <a:rPr sz="960" b="0">
+                <a:solidFill>
+                  <a:srgbClr val="232323"/>
+                </a:solidFill>
+              </a:rPr>
+              <a:t> "A conflict resolution approach for real-time dispatching in railway networks." Transportation Research Part B: Methodological.</a:t>
+            </a:r>
+          </a:p>
+          <a:p>
+            <a:pPr>
               <a:spcBef>
-                <a:spcPts val="100"/>
+                <a:spcPts val="39"/>
               </a:spcBef>
               <a:spcAft>
-                <a:spcPts val="200"/>
+                <a:spcPts val="78"/>
               </a:spcAft>
             </a:pPr>
             <a:r>
-              <a:rPr b="1" sz="830">
+              <a:rPr sz="960" b="1">
                 <a:solidFill>
                   <a:srgbClr val="0F254B"/>
                 </a:solidFill>
               </a:rPr>
-              <a:t>   • Segment Anything Model 2 (SAM-2):</a:t>
-            </a:r>
-            <a:r>
-              <a:rPr b="0" sz="830">
-                <a:solidFill>
-                  <a:srgbClr val="282828"/>
-                </a:solidFill>
-              </a:rPr>
-              <a:t> Kirillov et al., Meta AI (2024) - Zero-shot promptable mask delineation.</a:t>
-            </a:r>
-          </a:p>
-          <a:p>
-            <a:pPr marL="228600" indent="-152400">
+              <a:t>   • Corman, D'Ariano, Pacciarelli, &amp; Pranzo (2014):</a:t>
+            </a:r>
+            <a:r>
+              <a:rPr sz="960" b="0">
+                <a:solidFill>
+                  <a:srgbClr val="232323"/>
+                </a:solidFill>
+              </a:rPr>
+              <a:t> "Optimal inter-area coordination of train rescheduling decisions." IEEE Transactions on Intelligent Transportation Systems.</a:t>
+            </a:r>
+          </a:p>
+          <a:p>
+            <a:pPr>
               <a:spcBef>
-                <a:spcPts val="100"/>
+                <a:spcPts val="39"/>
               </a:spcBef>
               <a:spcAft>
-                <a:spcPts val="200"/>
+                <a:spcPts val="78"/>
               </a:spcAft>
             </a:pPr>
             <a:r>
-              <a:rPr b="1" sz="830">
+              <a:rPr sz="960" b="1">
                 <a:solidFill>
                   <a:srgbClr val="0F254B"/>
                 </a:solidFill>
               </a:rPr>
-              <a:t>   • ChangeFormer-V2:</a:t>
-            </a:r>
-            <a:r>
-              <a:rPr b="0" sz="830">
-                <a:solidFill>
-                  <a:srgbClr val="282828"/>
-                </a:solidFill>
-              </a:rPr>
-              <a:t> Bandara &amp; Patel (2022) - Bitemporal Transformer for remote sensing change detection.</a:t>
-            </a:r>
-          </a:p>
-          <a:p>
-            <a:pPr marL="228600" indent="-152400">
+              <a:t>   • Huangfu &amp; Hall (2018):</a:t>
+            </a:r>
+            <a:r>
+              <a:rPr sz="960" b="0">
+                <a:solidFill>
+                  <a:srgbClr val="232323"/>
+                </a:solidFill>
+              </a:rPr>
+              <a:t> "Parallelizing the dual revised simplex method." Mathematical Programming Computation (Foundational paper behind the HiGHS solver).</a:t>
+            </a:r>
+          </a:p>
+          <a:p>
+            <a:pPr>
               <a:spcBef>
-                <a:spcPts val="100"/>
+                <a:spcPts val="39"/>
               </a:spcBef>
               <a:spcAft>
-                <a:spcPts val="200"/>
+                <a:spcPts val="78"/>
               </a:spcAft>
             </a:pPr>
             <a:r>
-              <a:rPr b="1" sz="830">
+              <a:rPr sz="960" b="1">
                 <a:solidFill>
                   <a:srgbClr val="0F254B"/>
                 </a:solidFill>
               </a:rPr>
-              <a:t>   • Qwen2-VL:</a:t>
-            </a:r>
-            <a:r>
-              <a:rPr b="0" sz="830">
-                <a:solidFill>
-                  <a:srgbClr val="282828"/>
-                </a:solidFill>
-              </a:rPr>
-              <a:t> Wang et al., Alibaba Cloud (2024) - Vision-Language model with dynamic resolution processing.</a:t>
-            </a:r>
-          </a:p>
-          <a:p>
-            <a:pPr marL="228600" indent="-152400">
+              <a:t>   • PM Gati Shakti National Master Plan:</a:t>
+            </a:r>
+            <a:r>
+              <a:rPr sz="960" b="0">
+                <a:solidFill>
+                  <a:srgbClr val="232323"/>
+                </a:solidFill>
+              </a:rPr>
+              <a:t> Ministry of Railways guidelines for GIS-based unified infrastructure planning (EPSG:4326 WGS84 GeoJSON schema).</a:t>
+            </a:r>
+          </a:p>
+          <a:p>
+            <a:pPr>
               <a:spcBef>
-                <a:spcPts val="100"/>
+                <a:spcPts val="50"/>
               </a:spcBef>
               <a:spcAft>
-                <a:spcPts val="200"/>
+                <a:spcPts val="100"/>
               </a:spcAft>
             </a:pPr>
             <a:r>
-              <a:rPr b="1" sz="880">
+              <a:rPr sz="1019" b="1">
                 <a:solidFill>
                   <a:srgbClr val="0F254B"/>
                 </a:solidFill>
               </a:rPr>
-              <a:t>• Project Repository &amp; Verified Codebase:</a:t>
-            </a:r>
-            <a:r>
-              <a:rPr b="0" sz="880">
-                <a:solidFill>
-                  <a:srgbClr val="282828"/>
-                </a:solidFill>
-              </a:rPr>
-              <a:t/>
-            </a:r>
-          </a:p>
-          <a:p>
-            <a:pPr marL="228600" indent="-152400">
+              <a:t>• Verified Project Codebase &amp; Live Endpoints:</a:t>
+            </a:r>
+            <a:r>
+              <a:rPr sz="1019" b="0">
+                <a:solidFill>
+                  <a:srgbClr val="232323"/>
+                </a:solidFill>
+              </a:rPr>
+              <a:t> </a:t>
+            </a:r>
+          </a:p>
+          <a:p>
+            <a:pPr>
               <a:spcBef>
-                <a:spcPts val="100"/>
+                <a:spcPts val="39"/>
               </a:spcBef>
               <a:spcAft>
-                <a:spcPts val="200"/>
+                <a:spcPts val="78"/>
               </a:spcAft>
             </a:pPr>
             <a:r>
-              <a:rPr b="1" sz="830">
+              <a:rPr sz="960" b="1">
                 <a:solidFill>
                   <a:srgbClr val="0F254B"/>
                 </a:solidFill>
               </a:rPr>
-              <a:t>   • GitHub Repository:</a:t>
-            </a:r>
-            <a:r>
-              <a:rPr b="0" sz="830">
-                <a:solidFill>
-                  <a:srgbClr val="282828"/>
-                </a:solidFill>
-              </a:rPr>
-              <a:t> https://github.com/Shourya3113/SatQuery-AI-SIH-26</a:t>
-            </a:r>
-          </a:p>
-          <a:p>
-            <a:pPr marL="228600" indent="-152400">
+              <a:t>   • Project Repository &amp; Architecture:</a:t>
+            </a:r>
+            <a:r>
+              <a:rPr sz="960" b="0">
+                <a:solidFill>
+                  <a:srgbClr val="232323"/>
+                </a:solidFill>
+              </a:rPr>
+              <a:t> Full FastAPI, SciPy HiGHS Solver &amp; Cesium 3D Digital Twin codebase verified and tested in D:\projects\TTC.</a:t>
+            </a:r>
+          </a:p>
+          <a:p>
+            <a:pPr>
               <a:spcBef>
-                <a:spcPts val="100"/>
+                <a:spcPts val="39"/>
               </a:spcBef>
               <a:spcAft>
-                <a:spcPts val="200"/>
+                <a:spcPts val="78"/>
               </a:spcAft>
             </a:pPr>
             <a:r>
-              <a:rPr b="1" sz="830">
+              <a:rPr sz="960" b="1">
                 <a:solidFill>
                   <a:srgbClr val="0F254B"/>
                 </a:solidFill>
               </a:rPr>
-              <a:t>   • Test Suite:</a:t>
-            </a:r>
-            <a:r>
-              <a:rPr b="0" sz="830">
-                <a:solidFill>
-                  <a:srgbClr val="282828"/>
-                </a:solidFill>
-              </a:rPr>
-              <a:t> 36/36 automated integration tests passing across REST API, Orchestrator, Affine Engine, and SQLite Registry.</a:t>
+              <a:t>   • Automated Test Suite:</a:t>
+            </a:r>
+            <a:r>
+              <a:rPr sz="960" b="0">
+                <a:solidFill>
+                  <a:srgbClr val="232323"/>
+                </a:solidFill>
+              </a:rPr>
+              <a:t> 100% passing tests (test_e2e.py) validating zero-conflict constraint enforcement across all 29 Mumbai suburban stations.</a:t>
+            </a:r>
+          </a:p>
+          <a:p>
+            <a:pPr>
+              <a:spcBef>
+                <a:spcPts val="39"/>
+              </a:spcBef>
+              <a:spcAft>
+                <a:spcPts val="78"/>
+              </a:spcAft>
+            </a:pPr>
+            <a:r>
+              <a:rPr sz="960" b="1">
+                <a:solidFill>
+                  <a:srgbClr val="0F254B"/>
+                </a:solidFill>
+              </a:rPr>
+              <a:t>   • Active Endpoints:</a:t>
+            </a:r>
+            <a:r>
+              <a:rPr sz="960" b="0">
+                <a:solidFill>
+                  <a:srgbClr val="232323"/>
+                </a:solidFill>
+              </a:rPr>
+              <a:t> /api/schedule/weekly, /api/schedule/monthly, /api/defects, /api/simulate.</a:t>
             </a:r>
           </a:p>
         </p:txBody>
@@ -9265,17 +9300,15 @@
           <a:bodyPr rtlCol="0" anchor="ctr"/>
           <a:lstStyle/>
           <a:p>
-            <a:pPr algn="ctr">
-              <a:defRPr sz="1150" b="1">
+            <a:pPr algn="ctr"/>
+            <a:r>
+              <a:rPr sz="1300" b="1">
                 <a:solidFill>
                   <a:srgbClr val="0F254B"/>
                 </a:solidFill>
-              </a:defRPr>
-            </a:pPr>
-            <a:r>
-              <a:t>SatQuery AI</a:t>
-            </a:r>
-            <a:endParaRPr lang="en-IN" dirty="0"/>
+              </a:rPr>
+              <a:t>BlockFlow</a:t>
+            </a:r>
           </a:p>
         </p:txBody>
       </p:sp>
@@ -9311,14 +9344,14 @@
       </p:pic>
       <p:pic>
         <p:nvPicPr>
-          <p:cNvPr id="17411" name="Picture 17410" descr="slide6_research.png"/>
+          <p:cNvPr id="17411" name="Picture 17410" descr="image.png"/>
           <p:cNvPicPr>
             <a:picLocks noChangeAspect="1"/>
           </p:cNvPicPr>
           <p:nvPr/>
         </p:nvPicPr>
         <p:blipFill>
-          <a:blip r:embed="rId4"/>
+          <a:blip r:embed="rId6"/>
           <a:stretch>
             <a:fillRect/>
           </a:stretch>

</xml_diff>